<commit_message>
chore: Final pre-launch UI fixes, layout consistency, and media updates
</commit_message>
<xml_diff>
--- a/frontend/dist/RetailEdge_Executive_Presentation.pptx
+++ b/frontend/dist/RetailEdge_Executive_Presentation.pptx
@@ -45,9 +45,10 @@
     <p:sldId id="293" r:id="rId39"/>
     <p:sldId id="294" r:id="rId40"/>
     <p:sldId id="295" r:id="rId41"/>
+    <p:sldId id="296" r:id="rId42"/>
   </p:sldIdLst>
   <p:notesMasterIdLst>
-    <p:notesMasterId r:id="rId42"/>
+    <p:notesMasterId r:id="rId43"/>
   </p:notesMasterIdLst>
   <p:sldSz cx="12192000" cy="6858000"/>
   <p:notesSz cx="6858000" cy="12192000"/>
@@ -3557,6 +3558,94 @@
             <a:fld id="{F7021451-1387-4CA6-816F-3879F97B5CBC}" type="slidenum">
               <a:rPr lang="en-US"/>
               <a:t>40</a:t>
+            </a:fld>
+            <a:endParaRPr lang="en-US"/>
+          </a:p>
+        </p:txBody>
+      </p:sp>
+    </p:spTree>
+    <p:extLst>
+      <p:ext uri="{BB962C8B-B14F-4D97-AF65-F5344CB8AC3E}">
+        <p14:creationId xmlns:p14="http://schemas.microsoft.com/office/powerpoint/2010/main" val="1024086991"/>
+      </p:ext>
+    </p:extLst>
+  </p:cSld>
+  <p:clrMapOvr>
+    <a:masterClrMapping/>
+  </p:clrMapOvr>
+</p:notes>
+</file>
+
+<file path=ppt/notesSlides/notesSlide41.xml><?xml version="1.0" encoding="utf-8"?>
+<p:notes xmlns:a="http://schemas.openxmlformats.org/drawingml/2006/main" xmlns:r="http://schemas.openxmlformats.org/officeDocument/2006/relationships" xmlns:p="http://schemas.openxmlformats.org/presentationml/2006/main">
+  <p:cSld>
+    <p:spTree>
+      <p:nvGrpSpPr>
+        <p:cNvPr id="1" name=""/>
+        <p:cNvGrpSpPr/>
+        <p:nvPr/>
+      </p:nvGrpSpPr>
+      <p:grpSpPr>
+        <a:xfrm>
+          <a:off x="0" y="0"/>
+          <a:ext cx="0" cy="0"/>
+          <a:chOff x="0" y="0"/>
+          <a:chExt cx="0" cy="0"/>
+        </a:xfrm>
+      </p:grpSpPr>
+      <p:sp>
+        <p:nvSpPr>
+          <p:cNvPr id="2" name="Slide Image Placeholder 1"/>
+          <p:cNvSpPr>
+            <a:spLocks noGrp="1" noRot="1" noChangeAspect="1"/>
+          </p:cNvSpPr>
+          <p:nvPr>
+            <p:ph type="sldImg"/>
+          </p:nvPr>
+        </p:nvSpPr>
+        <p:spPr/>
+      </p:sp>
+      <p:sp>
+        <p:nvSpPr>
+          <p:cNvPr id="3" name="Notes Placeholder 2"/>
+          <p:cNvSpPr>
+            <a:spLocks noGrp="1"/>
+          </p:cNvSpPr>
+          <p:nvPr>
+            <p:ph type="body" idx="1"/>
+          </p:nvPr>
+        </p:nvSpPr>
+        <p:spPr/>
+        <p:txBody>
+          <a:bodyPr/>
+          <a:lstStyle/>
+          <a:p>
+            <a:r>
+              <a:rPr lang="en-US" dirty="0"/>
+              <a:t/>
+            </a:r>
+            <a:endParaRPr lang="en-US" dirty="0"/>
+          </a:p>
+        </p:txBody>
+      </p:sp>
+      <p:sp>
+        <p:nvSpPr>
+          <p:cNvPr id="4" name="Slide Number Placeholder 3"/>
+          <p:cNvSpPr>
+            <a:spLocks noGrp="1"/>
+          </p:cNvSpPr>
+          <p:nvPr>
+            <p:ph type="sldNum" sz="quarter" idx="10"/>
+          </p:nvPr>
+        </p:nvSpPr>
+        <p:spPr/>
+        <p:txBody>
+          <a:bodyPr/>
+          <a:lstStyle/>
+          <a:p>
+            <a:fld id="{F7021451-1387-4CA6-816F-3879F97B5CBC}" type="slidenum">
+              <a:rPr lang="en-US"/>
+              <a:t>41</a:t>
             </a:fld>
             <a:endParaRPr lang="en-US"/>
           </a:p>
@@ -10276,7 +10365,7 @@
                 <a:ea typeface="Arial" pitchFamily="34" charset="-122"/>
                 <a:cs typeface="Arial" pitchFamily="34" charset="-120"/>
               </a:rPr>
-              <a:t>EXECUTIVE OVERSIGHT</a:t>
+              <a:t>OPERATIONAL CONTROL</a:t>
             </a:r>
             <a:endParaRPr lang="en-US" sz="1000" dirty="0"/>
           </a:p>
@@ -10315,7 +10404,7 @@
                 <a:ea typeface="Arial" pitchFamily="34" charset="-122"/>
                 <a:cs typeface="Arial" pitchFamily="34" charset="-120"/>
               </a:rPr>
-              <a:t>Executive Performance Standing</a:t>
+              <a:t>Marketing Manager Dashboard &amp; Campaign Readiness</a:t>
             </a:r>
             <a:endParaRPr lang="en-US" sz="2400" dirty="0"/>
           </a:p>
@@ -10429,78 +10518,190 @@
                 <a:ea typeface="Arial" pitchFamily="34" charset="-122"/>
                 <a:cs typeface="Arial" pitchFamily="34" charset="-120"/>
               </a:rPr>
-              <a:t>Consolidate frontline execution metrics for senior management reviews:</a:t>
-            </a:r>
-            <a:endParaRPr lang="en-US" sz="1200" dirty="0"/>
-          </a:p>
-          <a:p>
-            <a:pPr indent="0" marL="0">
-              <a:lnSpc>
-                <a:spcPts val="1800"/>
-              </a:lnSpc>
-              <a:buNone/>
-            </a:pPr>
-            <a:endParaRPr lang="en-US" sz="1200" dirty="0"/>
-          </a:p>
-          <a:p>
-            <a:pPr indent="0" marL="0">
-              <a:lnSpc>
-                <a:spcPts val="1800"/>
-              </a:lnSpc>
-              <a:buNone/>
-            </a:pPr>
-            <a:r>
-              <a:rPr lang="en-US" sz="1200" dirty="0">
-                <a:solidFill>
-                  <a:srgbClr val="334155"/>
-                </a:solidFill>
-                <a:latin typeface="Arial" pitchFamily="34" charset="0"/>
-                <a:ea typeface="Arial" pitchFamily="34" charset="-122"/>
-                <a:cs typeface="Arial" pitchFamily="34" charset="-120"/>
-              </a:rPr>
-              <a:t>• Operations Index: Aggregates attendance, builder activities, and accuracy.</a:t>
-            </a:r>
-            <a:endParaRPr lang="en-US" sz="1200" dirty="0"/>
-          </a:p>
-          <a:p>
-            <a:pPr indent="0" marL="0">
-              <a:lnSpc>
-                <a:spcPts val="1800"/>
-              </a:lnSpc>
-              <a:buNone/>
-            </a:pPr>
-            <a:r>
-              <a:rPr lang="en-US" sz="1200" dirty="0">
-                <a:solidFill>
-                  <a:srgbClr val="334155"/>
-                </a:solidFill>
-                <a:latin typeface="Arial" pitchFamily="34" charset="0"/>
-                <a:ea typeface="Arial" pitchFamily="34" charset="-122"/>
-                <a:cs typeface="Arial" pitchFamily="34" charset="-120"/>
-              </a:rPr>
-              <a:t>• CSAT Tracker: Live rating feedback from promoters and customers (e.g. 4.8 / 5).</a:t>
-            </a:r>
-            <a:endParaRPr lang="en-US" sz="1200" dirty="0"/>
-          </a:p>
-          <a:p>
-            <a:pPr indent="0" marL="0">
-              <a:lnSpc>
-                <a:spcPts val="1800"/>
-              </a:lnSpc>
-              <a:buNone/>
-            </a:pPr>
-            <a:r>
-              <a:rPr lang="en-US" sz="1200" dirty="0">
-                <a:solidFill>
-                  <a:srgbClr val="334155"/>
-                </a:solidFill>
-                <a:latin typeface="Arial" pitchFamily="34" charset="0"/>
-                <a:ea typeface="Arial" pitchFamily="34" charset="-122"/>
-                <a:cs typeface="Arial" pitchFamily="34" charset="-120"/>
-              </a:rPr>
-              <a:t>• Sales Uplift: Demonstrates a 14-18% correlation between high quiz accuracy and store sales volume.</a:t>
-            </a:r>
-            <a:endParaRPr lang="en-US" sz="1200" dirty="0"/>
+              <a:t>Screen Name: Marketing Manager Dashboard</a:t>
+            </a:r>
+            <a:endParaRPr lang="en-US" sz="1200" dirty="0"/>
+          </a:p>
+          <a:p>
+            <a:pPr indent="0" marL="0">
+              <a:lnSpc>
+                <a:spcPts val="1800"/>
+              </a:lnSpc>
+              <a:buNone/>
+            </a:pPr>
+            <a:r>
+              <a:rPr lang="en-US" sz="1200" dirty="0">
+                <a:solidFill>
+                  <a:srgbClr val="334155"/>
+                </a:solidFill>
+                <a:latin typeface="Arial" pitchFamily="34" charset="0"/>
+                <a:ea typeface="Arial" pitchFamily="34" charset="-122"/>
+                <a:cs typeface="Arial" pitchFamily="34" charset="-120"/>
+              </a:rPr>
+              <a:t>Purpose: Monitor campaign health, timeline progress, and active quiz details.</a:t>
+            </a:r>
+            <a:endParaRPr lang="en-US" sz="1200" dirty="0"/>
+          </a:p>
+          <a:p>
+            <a:pPr indent="0" marL="0">
+              <a:lnSpc>
+                <a:spcPts val="1800"/>
+              </a:lnSpc>
+              <a:buNone/>
+            </a:pPr>
+            <a:r>
+              <a:rPr lang="en-US" sz="1200" dirty="0">
+                <a:solidFill>
+                  <a:srgbClr val="334155"/>
+                </a:solidFill>
+                <a:latin typeface="Arial" pitchFamily="34" charset="0"/>
+                <a:ea typeface="Arial" pitchFamily="34" charset="-122"/>
+                <a:cs typeface="Arial" pitchFamily="34" charset="-120"/>
+              </a:rPr>
+              <a:t>Features: Executive KPIs, campaign checklists, regional performance indices, live quiz status.</a:t>
+            </a:r>
+            <a:endParaRPr lang="en-US" sz="1200" dirty="0"/>
+          </a:p>
+          <a:p>
+            <a:pPr indent="0" marL="0">
+              <a:lnSpc>
+                <a:spcPts val="1800"/>
+              </a:lnSpc>
+              <a:buNone/>
+            </a:pPr>
+            <a:r>
+              <a:rPr lang="en-US" sz="1200" dirty="0">
+                <a:solidFill>
+                  <a:srgbClr val="334155"/>
+                </a:solidFill>
+                <a:latin typeface="Arial" pitchFamily="34" charset="0"/>
+                <a:ea typeface="Arial" pitchFamily="34" charset="-122"/>
+                <a:cs typeface="Arial" pitchFamily="34" charset="-120"/>
+              </a:rPr>
+              <a:t>Benefits: Keep marketing teams aligned on active product parameters and promoter readiness.</a:t>
+            </a:r>
+            <a:endParaRPr lang="en-US" sz="1200" dirty="0"/>
+          </a:p>
+          <a:p>
+            <a:pPr indent="0" marL="0">
+              <a:lnSpc>
+                <a:spcPts val="1800"/>
+              </a:lnSpc>
+              <a:buNone/>
+            </a:pPr>
+            <a:r>
+              <a:rPr lang="en-US" sz="1200" dirty="0">
+                <a:solidFill>
+                  <a:srgbClr val="334155"/>
+                </a:solidFill>
+                <a:latin typeface="Arial" pitchFamily="34" charset="0"/>
+                <a:ea typeface="Arial" pitchFamily="34" charset="-122"/>
+                <a:cs typeface="Arial" pitchFamily="34" charset="-120"/>
+              </a:rPr>
+              <a:t>Role: Marketing Manager</a:t>
+            </a:r>
+            <a:endParaRPr lang="en-US" sz="1200" dirty="0"/>
+          </a:p>
+          <a:p>
+            <a:pPr indent="0" marL="0">
+              <a:lnSpc>
+                <a:spcPts val="1800"/>
+              </a:lnSpc>
+              <a:buNone/>
+            </a:pPr>
+            <a:r>
+              <a:rPr lang="en-US" sz="1200" dirty="0">
+                <a:solidFill>
+                  <a:srgbClr val="334155"/>
+                </a:solidFill>
+                <a:latin typeface="Arial" pitchFamily="34" charset="0"/>
+                <a:ea typeface="Arial" pitchFamily="34" charset="-122"/>
+                <a:cs typeface="Arial" pitchFamily="34" charset="-120"/>
+              </a:rPr>
+              <a:t>Path: /pm-dashboard</a:t>
+            </a:r>
+            <a:endParaRPr lang="en-US" sz="1200" dirty="0"/>
+          </a:p>
+          <a:p>
+            <a:pPr indent="0" marL="0">
+              <a:lnSpc>
+                <a:spcPts val="1800"/>
+              </a:lnSpc>
+              <a:buNone/>
+            </a:pPr>
+            <a:r>
+              <a:rPr lang="en-US" sz="1200" dirty="0">
+                <a:solidFill>
+                  <a:srgbClr val="334155"/>
+                </a:solidFill>
+                <a:latin typeface="Arial" pitchFamily="34" charset="0"/>
+                <a:ea typeface="Arial" pitchFamily="34" charset="-122"/>
+                <a:cs typeface="Arial" pitchFamily="34" charset="-120"/>
+              </a:rPr>
+              <a:t>Outcome: Real-time marketing visibility and launch-readiness alignment.</a:t>
+            </a:r>
+            <a:endParaRPr lang="en-US" sz="1200" dirty="0"/>
+          </a:p>
+        </p:txBody>
+      </p:sp>
+      <p:sp>
+        <p:nvSpPr>
+          <p:cNvPr id="7" name="Shape 5"/>
+          <p:cNvSpPr/>
+          <p:nvPr/>
+        </p:nvSpPr>
+        <p:spPr>
+          <a:xfrm>
+            <a:off x="5852160" y="1371600"/>
+            <a:ext cx="5760720" cy="4389120"/>
+          </a:xfrm>
+          <a:prstGeom prst="rect">
+            <a:avLst/>
+          </a:prstGeom>
+          <a:solidFill>
+            <a:srgbClr val="E2E8F0"/>
+          </a:solidFill>
+          <a:ln w="19050">
+            <a:solidFill>
+              <a:srgbClr val="CBD5E1"/>
+            </a:solidFill>
+            <a:prstDash val="solid"/>
+          </a:ln>
+        </p:spPr>
+      </p:sp>
+      <p:sp>
+        <p:nvSpPr>
+          <p:cNvPr id="8" name="Text 6"/>
+          <p:cNvSpPr/>
+          <p:nvPr/>
+        </p:nvSpPr>
+        <p:spPr>
+          <a:xfrm>
+            <a:off x="5852160" y="3200400"/>
+            <a:ext cx="5760720" cy="731520"/>
+          </a:xfrm>
+          <a:prstGeom prst="rect">
+            <a:avLst/>
+          </a:prstGeom>
+          <a:noFill/>
+          <a:ln/>
+        </p:spPr>
+        <p:txBody>
+          <a:bodyPr wrap="square" rtlCol="0" anchor="ctr"/>
+          <a:lstStyle/>
+          <a:p>
+            <a:pPr algn="ctr" indent="0" marL="0">
+              <a:buNone/>
+            </a:pPr>
+            <a:r>
+              <a:rPr lang="en-US" sz="1400" dirty="0">
+                <a:solidFill>
+                  <a:srgbClr val="94A3B8"/>
+                </a:solidFill>
+              </a:rPr>
+              <a:t>[Screenshot: 09b_marketing_dashboard.png]</a:t>
+            </a:r>
+            <a:endParaRPr lang="en-US" sz="1400" dirty="0"/>
           </a:p>
         </p:txBody>
       </p:sp>
@@ -10569,7 +10770,7 @@
                 <a:ea typeface="Arial" pitchFamily="34" charset="-122"/>
                 <a:cs typeface="Arial" pitchFamily="34" charset="-120"/>
               </a:rPr>
-              <a:t>REPORTS &amp; EXPORTS</a:t>
+              <a:t>EXECUTIVE OVERSIGHT</a:t>
             </a:r>
             <a:endParaRPr lang="en-US" sz="1000" dirty="0"/>
           </a:p>
@@ -10608,7 +10809,7 @@
                 <a:ea typeface="Arial" pitchFamily="34" charset="-122"/>
                 <a:cs typeface="Arial" pitchFamily="34" charset="-120"/>
               </a:rPr>
-              <a:t>Reports Center &amp; Dynamic Filters</a:t>
+              <a:t>Executive Performance Standing</a:t>
             </a:r>
             <a:endParaRPr lang="en-US" sz="2400" dirty="0"/>
           </a:p>
@@ -10722,181 +10923,81 @@
                 <a:ea typeface="Arial" pitchFamily="34" charset="-122"/>
                 <a:cs typeface="Arial" pitchFamily="34" charset="-120"/>
               </a:rPr>
-              <a:t>Screen Name: Reports Page</a:t>
-            </a:r>
-            <a:endParaRPr lang="en-US" sz="1200" dirty="0"/>
-          </a:p>
-          <a:p>
-            <a:pPr indent="0" marL="0">
-              <a:lnSpc>
-                <a:spcPts val="1800"/>
-              </a:lnSpc>
-              <a:buNone/>
-            </a:pPr>
-            <a:r>
-              <a:rPr lang="en-US" sz="1200" dirty="0">
-                <a:solidFill>
-                  <a:srgbClr val="334155"/>
-                </a:solidFill>
-                <a:latin typeface="Arial" pitchFamily="34" charset="0"/>
-                <a:ea typeface="Arial" pitchFamily="34" charset="-122"/>
-                <a:cs typeface="Arial" pitchFamily="34" charset="-120"/>
-              </a:rPr>
-              <a:t>Purpose: Access and filter all training and evaluation logs.</a:t>
-            </a:r>
-            <a:endParaRPr lang="en-US" sz="1200" dirty="0"/>
-          </a:p>
-          <a:p>
-            <a:pPr indent="0" marL="0">
-              <a:lnSpc>
-                <a:spcPts val="1800"/>
-              </a:lnSpc>
-              <a:buNone/>
-            </a:pPr>
-            <a:r>
-              <a:rPr lang="en-US" sz="1200" dirty="0">
-                <a:solidFill>
-                  <a:srgbClr val="334155"/>
-                </a:solidFill>
-                <a:latin typeface="Arial" pitchFamily="34" charset="0"/>
-                <a:ea typeface="Arial" pitchFamily="34" charset="-122"/>
-                <a:cs typeface="Arial" pitchFamily="34" charset="-120"/>
-              </a:rPr>
-              <a:t>Features: Date range filters, project search, list of session reports, delete double submissions controls.</a:t>
-            </a:r>
-            <a:endParaRPr lang="en-US" sz="1200" dirty="0"/>
-          </a:p>
-          <a:p>
-            <a:pPr indent="0" marL="0">
-              <a:lnSpc>
-                <a:spcPts val="1800"/>
-              </a:lnSpc>
-              <a:buNone/>
-            </a:pPr>
-            <a:r>
-              <a:rPr lang="en-US" sz="1200" dirty="0">
-                <a:solidFill>
-                  <a:srgbClr val="334155"/>
-                </a:solidFill>
-                <a:latin typeface="Arial" pitchFamily="34" charset="0"/>
-                <a:ea typeface="Arial" pitchFamily="34" charset="-122"/>
-                <a:cs typeface="Arial" pitchFamily="34" charset="-120"/>
-              </a:rPr>
-              <a:t>Benefits: Ensures database records remain clean and provides easy navigation to individual scorecards.</a:t>
-            </a:r>
-            <a:endParaRPr lang="en-US" sz="1200" dirty="0"/>
-          </a:p>
-          <a:p>
-            <a:pPr indent="0" marL="0">
-              <a:lnSpc>
-                <a:spcPts val="1800"/>
-              </a:lnSpc>
-              <a:buNone/>
-            </a:pPr>
-            <a:r>
-              <a:rPr lang="en-US" sz="1200" dirty="0">
-                <a:solidFill>
-                  <a:srgbClr val="334155"/>
-                </a:solidFill>
-                <a:latin typeface="Arial" pitchFamily="34" charset="0"/>
-                <a:ea typeface="Arial" pitchFamily="34" charset="-122"/>
-                <a:cs typeface="Arial" pitchFamily="34" charset="-120"/>
-              </a:rPr>
-              <a:t>Role: Super Admin, Admin, Trainer, PM</a:t>
-            </a:r>
-            <a:endParaRPr lang="en-US" sz="1200" dirty="0"/>
-          </a:p>
-          <a:p>
-            <a:pPr indent="0" marL="0">
-              <a:lnSpc>
-                <a:spcPts val="1800"/>
-              </a:lnSpc>
-              <a:buNone/>
-            </a:pPr>
-            <a:r>
-              <a:rPr lang="en-US" sz="1200" dirty="0">
-                <a:solidFill>
-                  <a:srgbClr val="334155"/>
-                </a:solidFill>
-                <a:latin typeface="Arial" pitchFamily="34" charset="0"/>
-                <a:ea typeface="Arial" pitchFamily="34" charset="-122"/>
-                <a:cs typeface="Arial" pitchFamily="34" charset="-120"/>
-              </a:rPr>
-              <a:t>Path: /reports</a:t>
-            </a:r>
-            <a:endParaRPr lang="en-US" sz="1200" dirty="0"/>
-          </a:p>
-          <a:p>
-            <a:pPr indent="0" marL="0">
-              <a:lnSpc>
-                <a:spcPts val="1800"/>
-              </a:lnSpc>
-              <a:buNone/>
-            </a:pPr>
-            <a:r>
-              <a:rPr lang="en-US" sz="1200" dirty="0">
-                <a:solidFill>
-                  <a:srgbClr val="334155"/>
-                </a:solidFill>
-                <a:latin typeface="Arial" pitchFamily="34" charset="0"/>
-                <a:ea typeface="Arial" pitchFamily="34" charset="-122"/>
-                <a:cs typeface="Arial" pitchFamily="34" charset="-120"/>
-              </a:rPr>
-              <a:t>Outcome: Instant retrieval of historic assessment data and compliance audits.</a:t>
-            </a:r>
-            <a:endParaRPr lang="en-US" sz="1200" dirty="0"/>
-          </a:p>
-        </p:txBody>
-      </p:sp>
-      <p:sp>
-        <p:nvSpPr>
-          <p:cNvPr id="7" name="Shape 5"/>
-          <p:cNvSpPr/>
-          <p:nvPr/>
-        </p:nvSpPr>
-        <p:spPr>
-          <a:xfrm>
-            <a:off x="5852160" y="1371600"/>
-            <a:ext cx="5760720" cy="4389120"/>
-          </a:xfrm>
-          <a:prstGeom prst="rect">
-            <a:avLst/>
-          </a:prstGeom>
-          <a:solidFill>
-            <a:srgbClr val="FFFFFF"/>
-          </a:solidFill>
-          <a:ln w="19050">
-            <a:solidFill>
-              <a:srgbClr val="CBD5E1"/>
-            </a:solidFill>
-            <a:prstDash val="solid"/>
-          </a:ln>
-        </p:spPr>
-      </p:sp>
-      <p:pic>
-        <p:nvPicPr>
-          <p:cNvPr id="8" name="Image 0" descr="D:\Desktop\quizhive _ lms\scratch\screenshots\28_reports_center.png">    </p:cNvPr>
-          <p:cNvPicPr>
-            <a:picLocks noChangeAspect="1"/>
-          </p:cNvPicPr>
-          <p:nvPr/>
-        </p:nvPicPr>
-        <p:blipFill>
-          <a:blip r:embed="rId1"/>
-          <a:stretch>
-            <a:fillRect/>
-          </a:stretch>
-        </p:blipFill>
-        <p:spPr>
-          <a:xfrm>
-            <a:off x="5897880" y="1417320"/>
-            <a:ext cx="5669280" cy="4297680"/>
-          </a:xfrm>
-          <a:prstGeom prst="rect">
-            <a:avLst/>
-          </a:prstGeom>
-        </p:spPr>
-      </p:pic>
+              <a:t>Consolidate frontline execution metrics for senior management reviews:</a:t>
+            </a:r>
+            <a:endParaRPr lang="en-US" sz="1200" dirty="0"/>
+          </a:p>
+          <a:p>
+            <a:pPr indent="0" marL="0">
+              <a:lnSpc>
+                <a:spcPts val="1800"/>
+              </a:lnSpc>
+              <a:buNone/>
+            </a:pPr>
+            <a:endParaRPr lang="en-US" sz="1200" dirty="0"/>
+          </a:p>
+          <a:p>
+            <a:pPr indent="0" marL="0">
+              <a:lnSpc>
+                <a:spcPts val="1800"/>
+              </a:lnSpc>
+              <a:buNone/>
+            </a:pPr>
+            <a:r>
+              <a:rPr lang="en-US" sz="1200" dirty="0">
+                <a:solidFill>
+                  <a:srgbClr val="334155"/>
+                </a:solidFill>
+                <a:latin typeface="Arial" pitchFamily="34" charset="0"/>
+                <a:ea typeface="Arial" pitchFamily="34" charset="-122"/>
+                <a:cs typeface="Arial" pitchFamily="34" charset="-120"/>
+              </a:rPr>
+              <a:t>• Operations Index: Aggregates attendance, builder activities, and accuracy.</a:t>
+            </a:r>
+            <a:endParaRPr lang="en-US" sz="1200" dirty="0"/>
+          </a:p>
+          <a:p>
+            <a:pPr indent="0" marL="0">
+              <a:lnSpc>
+                <a:spcPts val="1800"/>
+              </a:lnSpc>
+              <a:buNone/>
+            </a:pPr>
+            <a:r>
+              <a:rPr lang="en-US" sz="1200" dirty="0">
+                <a:solidFill>
+                  <a:srgbClr val="334155"/>
+                </a:solidFill>
+                <a:latin typeface="Arial" pitchFamily="34" charset="0"/>
+                <a:ea typeface="Arial" pitchFamily="34" charset="-122"/>
+                <a:cs typeface="Arial" pitchFamily="34" charset="-120"/>
+              </a:rPr>
+              <a:t>• CSAT Tracker: Live rating feedback from promoters and customers (e.g. 4.8 / 5).</a:t>
+            </a:r>
+            <a:endParaRPr lang="en-US" sz="1200" dirty="0"/>
+          </a:p>
+          <a:p>
+            <a:pPr indent="0" marL="0">
+              <a:lnSpc>
+                <a:spcPts val="1800"/>
+              </a:lnSpc>
+              <a:buNone/>
+            </a:pPr>
+            <a:r>
+              <a:rPr lang="en-US" sz="1200" dirty="0">
+                <a:solidFill>
+                  <a:srgbClr val="334155"/>
+                </a:solidFill>
+                <a:latin typeface="Arial" pitchFamily="34" charset="0"/>
+                <a:ea typeface="Arial" pitchFamily="34" charset="-122"/>
+                <a:cs typeface="Arial" pitchFamily="34" charset="-120"/>
+              </a:rPr>
+              <a:t>• Sales Uplift: Demonstrates a 14-18% correlation between high quiz accuracy and store sales volume.</a:t>
+            </a:r>
+            <a:endParaRPr lang="en-US" sz="1200" dirty="0"/>
+          </a:p>
+        </p:txBody>
+      </p:sp>
     </p:spTree>
   </p:cSld>
   <p:clrMapOvr>
@@ -11001,7 +11102,7 @@
                 <a:ea typeface="Arial" pitchFamily="34" charset="-122"/>
                 <a:cs typeface="Arial" pitchFamily="34" charset="-120"/>
               </a:rPr>
-              <a:t>Dynamic PDF &amp; PowerPoint Reports</a:t>
+              <a:t>Reports Center &amp; Dynamic Filters</a:t>
             </a:r>
             <a:endParaRPr lang="en-US" sz="2400" dirty="0"/>
           </a:p>
@@ -11115,81 +11216,181 @@
                 <a:ea typeface="Arial" pitchFamily="34" charset="-122"/>
                 <a:cs typeface="Arial" pitchFamily="34" charset="-120"/>
               </a:rPr>
-              <a:t>Generate professional presentation decks and audit reports in one click:</a:t>
-            </a:r>
-            <a:endParaRPr lang="en-US" sz="1200" dirty="0"/>
-          </a:p>
-          <a:p>
-            <a:pPr indent="0" marL="0">
-              <a:lnSpc>
-                <a:spcPts val="1800"/>
-              </a:lnSpc>
-              <a:buNone/>
-            </a:pPr>
-            <a:endParaRPr lang="en-US" sz="1200" dirty="0"/>
-          </a:p>
-          <a:p>
-            <a:pPr indent="0" marL="0">
-              <a:lnSpc>
-                <a:spcPts val="1800"/>
-              </a:lnSpc>
-              <a:buNone/>
-            </a:pPr>
-            <a:r>
-              <a:rPr lang="en-US" sz="1200" dirty="0">
-                <a:solidFill>
-                  <a:srgbClr val="334155"/>
-                </a:solidFill>
-                <a:latin typeface="Arial" pitchFamily="34" charset="0"/>
-                <a:ea typeface="Arial" pitchFamily="34" charset="-122"/>
-                <a:cs typeface="Arial" pitchFamily="34" charset="-120"/>
-              </a:rPr>
-              <a:t>• Slide Exports: Generates customized slide decks with KPIs, leaderboard summaries, and action plans.</a:t>
-            </a:r>
-            <a:endParaRPr lang="en-US" sz="1200" dirty="0"/>
-          </a:p>
-          <a:p>
-            <a:pPr indent="0" marL="0">
-              <a:lnSpc>
-                <a:spcPts val="1800"/>
-              </a:lnSpc>
-              <a:buNone/>
-            </a:pPr>
-            <a:r>
-              <a:rPr lang="en-US" sz="1200" dirty="0">
-                <a:solidFill>
-                  <a:srgbClr val="334155"/>
-                </a:solidFill>
-                <a:latin typeface="Arial" pitchFamily="34" charset="0"/>
-                <a:ea typeface="Arial" pitchFamily="34" charset="-122"/>
-                <a:cs typeface="Arial" pitchFamily="34" charset="-120"/>
-              </a:rPr>
-              <a:t>• PDF Summaries: Programmatically renders clean landscape PDF scorecards for training sign-offs.</a:t>
-            </a:r>
-            <a:endParaRPr lang="en-US" sz="1200" dirty="0"/>
-          </a:p>
-          <a:p>
-            <a:pPr indent="0" marL="0">
-              <a:lnSpc>
-                <a:spcPts val="1800"/>
-              </a:lnSpc>
-              <a:buNone/>
-            </a:pPr>
-            <a:r>
-              <a:rPr lang="en-US" sz="1200" dirty="0">
-                <a:solidFill>
-                  <a:srgbClr val="334155"/>
-                </a:solidFill>
-                <a:latin typeface="Arial" pitchFamily="34" charset="0"/>
-                <a:ea typeface="Arial" pitchFamily="34" charset="-122"/>
-                <a:cs typeface="Arial" pitchFamily="34" charset="-120"/>
-              </a:rPr>
-              <a:t>• Multi-Device Access: Download links are exposed via Cloudflare tunnel, accessible from any external browser.</a:t>
-            </a:r>
-            <a:endParaRPr lang="en-US" sz="1200" dirty="0"/>
-          </a:p>
-        </p:txBody>
-      </p:sp>
+              <a:t>Screen Name: Reports Page</a:t>
+            </a:r>
+            <a:endParaRPr lang="en-US" sz="1200" dirty="0"/>
+          </a:p>
+          <a:p>
+            <a:pPr indent="0" marL="0">
+              <a:lnSpc>
+                <a:spcPts val="1800"/>
+              </a:lnSpc>
+              <a:buNone/>
+            </a:pPr>
+            <a:r>
+              <a:rPr lang="en-US" sz="1200" dirty="0">
+                <a:solidFill>
+                  <a:srgbClr val="334155"/>
+                </a:solidFill>
+                <a:latin typeface="Arial" pitchFamily="34" charset="0"/>
+                <a:ea typeface="Arial" pitchFamily="34" charset="-122"/>
+                <a:cs typeface="Arial" pitchFamily="34" charset="-120"/>
+              </a:rPr>
+              <a:t>Purpose: Access and filter all training and evaluation logs.</a:t>
+            </a:r>
+            <a:endParaRPr lang="en-US" sz="1200" dirty="0"/>
+          </a:p>
+          <a:p>
+            <a:pPr indent="0" marL="0">
+              <a:lnSpc>
+                <a:spcPts val="1800"/>
+              </a:lnSpc>
+              <a:buNone/>
+            </a:pPr>
+            <a:r>
+              <a:rPr lang="en-US" sz="1200" dirty="0">
+                <a:solidFill>
+                  <a:srgbClr val="334155"/>
+                </a:solidFill>
+                <a:latin typeface="Arial" pitchFamily="34" charset="0"/>
+                <a:ea typeface="Arial" pitchFamily="34" charset="-122"/>
+                <a:cs typeface="Arial" pitchFamily="34" charset="-120"/>
+              </a:rPr>
+              <a:t>Features: Date range filters, project search, list of session reports, delete double submissions controls.</a:t>
+            </a:r>
+            <a:endParaRPr lang="en-US" sz="1200" dirty="0"/>
+          </a:p>
+          <a:p>
+            <a:pPr indent="0" marL="0">
+              <a:lnSpc>
+                <a:spcPts val="1800"/>
+              </a:lnSpc>
+              <a:buNone/>
+            </a:pPr>
+            <a:r>
+              <a:rPr lang="en-US" sz="1200" dirty="0">
+                <a:solidFill>
+                  <a:srgbClr val="334155"/>
+                </a:solidFill>
+                <a:latin typeface="Arial" pitchFamily="34" charset="0"/>
+                <a:ea typeface="Arial" pitchFamily="34" charset="-122"/>
+                <a:cs typeface="Arial" pitchFamily="34" charset="-120"/>
+              </a:rPr>
+              <a:t>Benefits: Ensures database records remain clean and provides easy navigation to individual scorecards.</a:t>
+            </a:r>
+            <a:endParaRPr lang="en-US" sz="1200" dirty="0"/>
+          </a:p>
+          <a:p>
+            <a:pPr indent="0" marL="0">
+              <a:lnSpc>
+                <a:spcPts val="1800"/>
+              </a:lnSpc>
+              <a:buNone/>
+            </a:pPr>
+            <a:r>
+              <a:rPr lang="en-US" sz="1200" dirty="0">
+                <a:solidFill>
+                  <a:srgbClr val="334155"/>
+                </a:solidFill>
+                <a:latin typeface="Arial" pitchFamily="34" charset="0"/>
+                <a:ea typeface="Arial" pitchFamily="34" charset="-122"/>
+                <a:cs typeface="Arial" pitchFamily="34" charset="-120"/>
+              </a:rPr>
+              <a:t>Role: Super Admin, Admin, Trainer, PM</a:t>
+            </a:r>
+            <a:endParaRPr lang="en-US" sz="1200" dirty="0"/>
+          </a:p>
+          <a:p>
+            <a:pPr indent="0" marL="0">
+              <a:lnSpc>
+                <a:spcPts val="1800"/>
+              </a:lnSpc>
+              <a:buNone/>
+            </a:pPr>
+            <a:r>
+              <a:rPr lang="en-US" sz="1200" dirty="0">
+                <a:solidFill>
+                  <a:srgbClr val="334155"/>
+                </a:solidFill>
+                <a:latin typeface="Arial" pitchFamily="34" charset="0"/>
+                <a:ea typeface="Arial" pitchFamily="34" charset="-122"/>
+                <a:cs typeface="Arial" pitchFamily="34" charset="-120"/>
+              </a:rPr>
+              <a:t>Path: /reports</a:t>
+            </a:r>
+            <a:endParaRPr lang="en-US" sz="1200" dirty="0"/>
+          </a:p>
+          <a:p>
+            <a:pPr indent="0" marL="0">
+              <a:lnSpc>
+                <a:spcPts val="1800"/>
+              </a:lnSpc>
+              <a:buNone/>
+            </a:pPr>
+            <a:r>
+              <a:rPr lang="en-US" sz="1200" dirty="0">
+                <a:solidFill>
+                  <a:srgbClr val="334155"/>
+                </a:solidFill>
+                <a:latin typeface="Arial" pitchFamily="34" charset="0"/>
+                <a:ea typeface="Arial" pitchFamily="34" charset="-122"/>
+                <a:cs typeface="Arial" pitchFamily="34" charset="-120"/>
+              </a:rPr>
+              <a:t>Outcome: Instant retrieval of historic assessment data and compliance audits.</a:t>
+            </a:r>
+            <a:endParaRPr lang="en-US" sz="1200" dirty="0"/>
+          </a:p>
+        </p:txBody>
+      </p:sp>
+      <p:sp>
+        <p:nvSpPr>
+          <p:cNvPr id="7" name="Shape 5"/>
+          <p:cNvSpPr/>
+          <p:nvPr/>
+        </p:nvSpPr>
+        <p:spPr>
+          <a:xfrm>
+            <a:off x="5852160" y="1371600"/>
+            <a:ext cx="5760720" cy="4389120"/>
+          </a:xfrm>
+          <a:prstGeom prst="rect">
+            <a:avLst/>
+          </a:prstGeom>
+          <a:solidFill>
+            <a:srgbClr val="FFFFFF"/>
+          </a:solidFill>
+          <a:ln w="19050">
+            <a:solidFill>
+              <a:srgbClr val="CBD5E1"/>
+            </a:solidFill>
+            <a:prstDash val="solid"/>
+          </a:ln>
+        </p:spPr>
+      </p:sp>
+      <p:pic>
+        <p:nvPicPr>
+          <p:cNvPr id="8" name="Image 0" descr="D:\Desktop\quizhive _ lms\scratch\screenshots\28_reports_center.png">    </p:cNvPr>
+          <p:cNvPicPr>
+            <a:picLocks noChangeAspect="1"/>
+          </p:cNvPicPr>
+          <p:nvPr/>
+        </p:nvPicPr>
+        <p:blipFill>
+          <a:blip r:embed="rId1"/>
+          <a:stretch>
+            <a:fillRect/>
+          </a:stretch>
+        </p:blipFill>
+        <p:spPr>
+          <a:xfrm>
+            <a:off x="5897880" y="1417320"/>
+            <a:ext cx="5669280" cy="4297680"/>
+          </a:xfrm>
+          <a:prstGeom prst="rect">
+            <a:avLst/>
+          </a:prstGeom>
+        </p:spPr>
+      </p:pic>
     </p:spTree>
   </p:cSld>
   <p:clrMapOvr>
@@ -11294,7 +11495,7 @@
                 <a:ea typeface="Arial" pitchFamily="34" charset="-122"/>
                 <a:cs typeface="Arial" pitchFamily="34" charset="-120"/>
               </a:rPr>
-              <a:t>Dynamic Excel Export Engine</a:t>
+              <a:t>Dynamic PDF &amp; PowerPoint Reports</a:t>
             </a:r>
             <a:endParaRPr lang="en-US" sz="2400" dirty="0"/>
           </a:p>
@@ -11408,76 +11609,76 @@
                 <a:ea typeface="Arial" pitchFamily="34" charset="-122"/>
                 <a:cs typeface="Arial" pitchFamily="34" charset="-120"/>
               </a:rPr>
-              <a:t>Download detailed spreadsheets containing raw operational metrics:</a:t>
-            </a:r>
-            <a:endParaRPr lang="en-US" sz="1200" dirty="0"/>
-          </a:p>
-          <a:p>
-            <a:pPr indent="0" marL="0">
-              <a:lnSpc>
-                <a:spcPts val="1800"/>
-              </a:lnSpc>
-              <a:buNone/>
-            </a:pPr>
-            <a:endParaRPr lang="en-US" sz="1200" dirty="0"/>
-          </a:p>
-          <a:p>
-            <a:pPr indent="0" marL="0">
-              <a:lnSpc>
-                <a:spcPts val="1800"/>
-              </a:lnSpc>
-              <a:buNone/>
-            </a:pPr>
-            <a:r>
-              <a:rPr lang="en-US" sz="1200" dirty="0">
-                <a:solidFill>
-                  <a:srgbClr val="334155"/>
-                </a:solidFill>
-                <a:latin typeface="Arial" pitchFamily="34" charset="0"/>
-                <a:ea typeface="Arial" pitchFamily="34" charset="-122"/>
-                <a:cs typeface="Arial" pitchFamily="34" charset="-120"/>
-              </a:rPr>
-              <a:t>• Raw Data Sheets: Captures employee IDs, correct answers counts, total response times, store locations.</a:t>
-            </a:r>
-            <a:endParaRPr lang="en-US" sz="1200" dirty="0"/>
-          </a:p>
-          <a:p>
-            <a:pPr indent="0" marL="0">
-              <a:lnSpc>
-                <a:spcPts val="1800"/>
-              </a:lnSpc>
-              <a:buNone/>
-            </a:pPr>
-            <a:r>
-              <a:rPr lang="en-US" sz="1200" dirty="0">
-                <a:solidFill>
-                  <a:srgbClr val="334155"/>
-                </a:solidFill>
-                <a:latin typeface="Arial" pitchFamily="34" charset="0"/>
-                <a:ea typeface="Arial" pitchFamily="34" charset="-122"/>
-                <a:cs typeface="Arial" pitchFamily="34" charset="-120"/>
-              </a:rPr>
-              <a:t>• Pre-Formatted Tables: Clean layouts with auto-adjusted column widths and color-coded score classifications.</a:t>
-            </a:r>
-            <a:endParaRPr lang="en-US" sz="1200" dirty="0"/>
-          </a:p>
-          <a:p>
-            <a:pPr indent="0" marL="0">
-              <a:lnSpc>
-                <a:spcPts val="1800"/>
-              </a:lnSpc>
-              <a:buNone/>
-            </a:pPr>
-            <a:r>
-              <a:rPr lang="en-US" sz="1200" dirty="0">
-                <a:solidFill>
-                  <a:srgbClr val="334155"/>
-                </a:solidFill>
-                <a:latin typeface="Arial" pitchFamily="34" charset="0"/>
-                <a:ea typeface="Arial" pitchFamily="34" charset="-122"/>
-                <a:cs typeface="Arial" pitchFamily="34" charset="-120"/>
-              </a:rPr>
-              <a:t>• ERP Integration: Output formats match standard formats for easy upload to SAP/Unilever dashboards.</a:t>
+              <a:t>Generate professional presentation decks and audit reports in one click:</a:t>
+            </a:r>
+            <a:endParaRPr lang="en-US" sz="1200" dirty="0"/>
+          </a:p>
+          <a:p>
+            <a:pPr indent="0" marL="0">
+              <a:lnSpc>
+                <a:spcPts val="1800"/>
+              </a:lnSpc>
+              <a:buNone/>
+            </a:pPr>
+            <a:endParaRPr lang="en-US" sz="1200" dirty="0"/>
+          </a:p>
+          <a:p>
+            <a:pPr indent="0" marL="0">
+              <a:lnSpc>
+                <a:spcPts val="1800"/>
+              </a:lnSpc>
+              <a:buNone/>
+            </a:pPr>
+            <a:r>
+              <a:rPr lang="en-US" sz="1200" dirty="0">
+                <a:solidFill>
+                  <a:srgbClr val="334155"/>
+                </a:solidFill>
+                <a:latin typeface="Arial" pitchFamily="34" charset="0"/>
+                <a:ea typeface="Arial" pitchFamily="34" charset="-122"/>
+                <a:cs typeface="Arial" pitchFamily="34" charset="-120"/>
+              </a:rPr>
+              <a:t>• Slide Exports: Generates customized slide decks with KPIs, leaderboard summaries, and action plans.</a:t>
+            </a:r>
+            <a:endParaRPr lang="en-US" sz="1200" dirty="0"/>
+          </a:p>
+          <a:p>
+            <a:pPr indent="0" marL="0">
+              <a:lnSpc>
+                <a:spcPts val="1800"/>
+              </a:lnSpc>
+              <a:buNone/>
+            </a:pPr>
+            <a:r>
+              <a:rPr lang="en-US" sz="1200" dirty="0">
+                <a:solidFill>
+                  <a:srgbClr val="334155"/>
+                </a:solidFill>
+                <a:latin typeface="Arial" pitchFamily="34" charset="0"/>
+                <a:ea typeface="Arial" pitchFamily="34" charset="-122"/>
+                <a:cs typeface="Arial" pitchFamily="34" charset="-120"/>
+              </a:rPr>
+              <a:t>• PDF Summaries: Programmatically renders clean landscape PDF scorecards for training sign-offs.</a:t>
+            </a:r>
+            <a:endParaRPr lang="en-US" sz="1200" dirty="0"/>
+          </a:p>
+          <a:p>
+            <a:pPr indent="0" marL="0">
+              <a:lnSpc>
+                <a:spcPts val="1800"/>
+              </a:lnSpc>
+              <a:buNone/>
+            </a:pPr>
+            <a:r>
+              <a:rPr lang="en-US" sz="1200" dirty="0">
+                <a:solidFill>
+                  <a:srgbClr val="334155"/>
+                </a:solidFill>
+                <a:latin typeface="Arial" pitchFamily="34" charset="0"/>
+                <a:ea typeface="Arial" pitchFamily="34" charset="-122"/>
+                <a:cs typeface="Arial" pitchFamily="34" charset="-120"/>
+              </a:rPr>
+              <a:t>• Multi-Device Access: Download links are exposed via Cloudflare tunnel, accessible from any external browser.</a:t>
             </a:r>
             <a:endParaRPr lang="en-US" sz="1200" dirty="0"/>
           </a:p>
@@ -11548,7 +11749,7 @@
                 <a:ea typeface="Arial" pitchFamily="34" charset="-122"/>
                 <a:cs typeface="Arial" pitchFamily="34" charset="-120"/>
               </a:rPr>
-              <a:t>INFRASTRUCTURE</a:t>
+              <a:t>REPORTS &amp; EXPORTS</a:t>
             </a:r>
             <a:endParaRPr lang="en-US" sz="1000" dirty="0"/>
           </a:p>
@@ -11587,7 +11788,7 @@
                 <a:ea typeface="Arial" pitchFamily="34" charset="-122"/>
                 <a:cs typeface="Arial" pitchFamily="34" charset="-120"/>
               </a:rPr>
-              <a:t>Real-Time WebSocket Architecture</a:t>
+              <a:t>Dynamic Excel Export Engine</a:t>
             </a:r>
             <a:endParaRPr lang="en-US" sz="2400" dirty="0"/>
           </a:p>
@@ -11701,76 +11902,76 @@
                 <a:ea typeface="Arial" pitchFamily="34" charset="-122"/>
                 <a:cs typeface="Arial" pitchFamily="34" charset="-120"/>
               </a:rPr>
-              <a:t>State-of-the-art background communication keeps the team synchronized:</a:t>
-            </a:r>
-            <a:endParaRPr lang="en-US" sz="1200" dirty="0"/>
-          </a:p>
-          <a:p>
-            <a:pPr indent="0" marL="0">
-              <a:lnSpc>
-                <a:spcPts val="1800"/>
-              </a:lnSpc>
-              <a:buNone/>
-            </a:pPr>
-            <a:endParaRPr lang="en-US" sz="1200" dirty="0"/>
-          </a:p>
-          <a:p>
-            <a:pPr indent="0" marL="0">
-              <a:lnSpc>
-                <a:spcPts val="1800"/>
-              </a:lnSpc>
-              <a:buNone/>
-            </a:pPr>
-            <a:r>
-              <a:rPr lang="en-US" sz="1200" dirty="0">
-                <a:solidFill>
-                  <a:srgbClr val="334155"/>
-                </a:solidFill>
-                <a:latin typeface="Arial" pitchFamily="34" charset="0"/>
-                <a:ea typeface="Arial" pitchFamily="34" charset="-122"/>
-                <a:cs typeface="Arial" pitchFamily="34" charset="-120"/>
-              </a:rPr>
-              <a:t>• WebSocket Protocol: Establishes a bidirectional channel between the Express server and React client.</a:t>
-            </a:r>
-            <a:endParaRPr lang="en-US" sz="1200" dirty="0"/>
-          </a:p>
-          <a:p>
-            <a:pPr indent="0" marL="0">
-              <a:lnSpc>
-                <a:spcPts val="1800"/>
-              </a:lnSpc>
-              <a:buNone/>
-            </a:pPr>
-            <a:r>
-              <a:rPr lang="en-US" sz="1200" dirty="0">
-                <a:solidFill>
-                  <a:srgbClr val="334155"/>
-                </a:solidFill>
-                <a:latin typeface="Arial" pitchFamily="34" charset="0"/>
-                <a:ea typeface="Arial" pitchFamily="34" charset="-122"/>
-                <a:cs typeface="Arial" pitchFamily="34" charset="-120"/>
-              </a:rPr>
-              <a:t>• Background Refresh: Dashboards update silently in the background without affecting screen viewing.</a:t>
-            </a:r>
-            <a:endParaRPr lang="en-US" sz="1200" dirty="0"/>
-          </a:p>
-          <a:p>
-            <a:pPr indent="0" marL="0">
-              <a:lnSpc>
-                <a:spcPts val="1800"/>
-              </a:lnSpc>
-              <a:buNone/>
-            </a:pPr>
-            <a:r>
-              <a:rPr lang="en-US" sz="1200" dirty="0">
-                <a:solidFill>
-                  <a:srgbClr val="334155"/>
-                </a:solidFill>
-                <a:latin typeface="Arial" pitchFamily="34" charset="0"/>
-                <a:ea typeface="Arial" pitchFamily="34" charset="-122"/>
-                <a:cs typeface="Arial" pitchFamily="34" charset="-120"/>
-              </a:rPr>
-              <a:t>• Event-Driven: Triggers update calls on events like live_session_finished, offline_response_submitted, report_deleted.</a:t>
+              <a:t>Download detailed spreadsheets containing raw operational metrics:</a:t>
+            </a:r>
+            <a:endParaRPr lang="en-US" sz="1200" dirty="0"/>
+          </a:p>
+          <a:p>
+            <a:pPr indent="0" marL="0">
+              <a:lnSpc>
+                <a:spcPts val="1800"/>
+              </a:lnSpc>
+              <a:buNone/>
+            </a:pPr>
+            <a:endParaRPr lang="en-US" sz="1200" dirty="0"/>
+          </a:p>
+          <a:p>
+            <a:pPr indent="0" marL="0">
+              <a:lnSpc>
+                <a:spcPts val="1800"/>
+              </a:lnSpc>
+              <a:buNone/>
+            </a:pPr>
+            <a:r>
+              <a:rPr lang="en-US" sz="1200" dirty="0">
+                <a:solidFill>
+                  <a:srgbClr val="334155"/>
+                </a:solidFill>
+                <a:latin typeface="Arial" pitchFamily="34" charset="0"/>
+                <a:ea typeface="Arial" pitchFamily="34" charset="-122"/>
+                <a:cs typeface="Arial" pitchFamily="34" charset="-120"/>
+              </a:rPr>
+              <a:t>• Raw Data Sheets: Captures employee IDs, correct answers counts, total response times, store locations.</a:t>
+            </a:r>
+            <a:endParaRPr lang="en-US" sz="1200" dirty="0"/>
+          </a:p>
+          <a:p>
+            <a:pPr indent="0" marL="0">
+              <a:lnSpc>
+                <a:spcPts val="1800"/>
+              </a:lnSpc>
+              <a:buNone/>
+            </a:pPr>
+            <a:r>
+              <a:rPr lang="en-US" sz="1200" dirty="0">
+                <a:solidFill>
+                  <a:srgbClr val="334155"/>
+                </a:solidFill>
+                <a:latin typeface="Arial" pitchFamily="34" charset="0"/>
+                <a:ea typeface="Arial" pitchFamily="34" charset="-122"/>
+                <a:cs typeface="Arial" pitchFamily="34" charset="-120"/>
+              </a:rPr>
+              <a:t>• Pre-Formatted Tables: Clean layouts with auto-adjusted column widths and color-coded score classifications.</a:t>
+            </a:r>
+            <a:endParaRPr lang="en-US" sz="1200" dirty="0"/>
+          </a:p>
+          <a:p>
+            <a:pPr indent="0" marL="0">
+              <a:lnSpc>
+                <a:spcPts val="1800"/>
+              </a:lnSpc>
+              <a:buNone/>
+            </a:pPr>
+            <a:r>
+              <a:rPr lang="en-US" sz="1200" dirty="0">
+                <a:solidFill>
+                  <a:srgbClr val="334155"/>
+                </a:solidFill>
+                <a:latin typeface="Arial" pitchFamily="34" charset="0"/>
+                <a:ea typeface="Arial" pitchFamily="34" charset="-122"/>
+                <a:cs typeface="Arial" pitchFamily="34" charset="-120"/>
+              </a:rPr>
+              <a:t>• ERP Integration: Output formats match standard formats for easy upload to SAP/Unilever dashboards.</a:t>
             </a:r>
             <a:endParaRPr lang="en-US" sz="1200" dirty="0"/>
           </a:p>
@@ -12254,7 +12455,7 @@
                 <a:ea typeface="Arial" pitchFamily="34" charset="-122"/>
                 <a:cs typeface="Arial" pitchFamily="34" charset="-120"/>
               </a:rPr>
-              <a:t>MOBILE UI &amp; PORTALS</a:t>
+              <a:t>INFRASTRUCTURE</a:t>
             </a:r>
             <a:endParaRPr lang="en-US" sz="1000" dirty="0"/>
           </a:p>
@@ -12293,7 +12494,7 @@
                 <a:ea typeface="Arial" pitchFamily="34" charset="-122"/>
                 <a:cs typeface="Arial" pitchFamily="34" charset="-120"/>
               </a:rPr>
-              <a:t>Mobile Interface Design &amp; Sign-In</a:t>
+              <a:t>Real-Time WebSocket Architecture</a:t>
             </a:r>
             <a:endParaRPr lang="en-US" sz="2400" dirty="0"/>
           </a:p>
@@ -12407,181 +12608,81 @@
                 <a:ea typeface="Arial" pitchFamily="34" charset="-122"/>
                 <a:cs typeface="Arial" pitchFamily="34" charset="-120"/>
               </a:rPr>
-              <a:t>Screen Name: Mobile Login Page</a:t>
-            </a:r>
-            <a:endParaRPr lang="en-US" sz="1200" dirty="0"/>
-          </a:p>
-          <a:p>
-            <a:pPr indent="0" marL="0">
-              <a:lnSpc>
-                <a:spcPts val="1800"/>
-              </a:lnSpc>
-              <a:buNone/>
-            </a:pPr>
-            <a:r>
-              <a:rPr lang="en-US" sz="1200" dirty="0">
-                <a:solidFill>
-                  <a:srgbClr val="334155"/>
-                </a:solidFill>
-                <a:latin typeface="Arial" pitchFamily="34" charset="0"/>
-                <a:ea typeface="Arial" pitchFamily="34" charset="-122"/>
-                <a:cs typeface="Arial" pitchFamily="34" charset="-120"/>
-              </a:rPr>
-              <a:t>Purpose: Portal access for field staff using mobile devices.</a:t>
-            </a:r>
-            <a:endParaRPr lang="en-US" sz="1200" dirty="0"/>
-          </a:p>
-          <a:p>
-            <a:pPr indent="0" marL="0">
-              <a:lnSpc>
-                <a:spcPts val="1800"/>
-              </a:lnSpc>
-              <a:buNone/>
-            </a:pPr>
-            <a:r>
-              <a:rPr lang="en-US" sz="1200" dirty="0">
-                <a:solidFill>
-                  <a:srgbClr val="334155"/>
-                </a:solidFill>
-                <a:latin typeface="Arial" pitchFamily="34" charset="0"/>
-                <a:ea typeface="Arial" pitchFamily="34" charset="-122"/>
-                <a:cs typeface="Arial" pitchFamily="34" charset="-120"/>
-              </a:rPr>
-              <a:t>Features: Responsive form fields, quick-tap inputs, low-data asset sizes, MASCOT tips overlay.</a:t>
-            </a:r>
-            <a:endParaRPr lang="en-US" sz="1200" dirty="0"/>
-          </a:p>
-          <a:p>
-            <a:pPr indent="0" marL="0">
-              <a:lnSpc>
-                <a:spcPts val="1800"/>
-              </a:lnSpc>
-              <a:buNone/>
-            </a:pPr>
-            <a:r>
-              <a:rPr lang="en-US" sz="1200" dirty="0">
-                <a:solidFill>
-                  <a:srgbClr val="334155"/>
-                </a:solidFill>
-                <a:latin typeface="Arial" pitchFamily="34" charset="0"/>
-                <a:ea typeface="Arial" pitchFamily="34" charset="-122"/>
-                <a:cs typeface="Arial" pitchFamily="34" charset="-120"/>
-              </a:rPr>
-              <a:t>Benefits: Smooth user experience on low-end Android smartphones; minimal bandwidth usage.</a:t>
-            </a:r>
-            <a:endParaRPr lang="en-US" sz="1200" dirty="0"/>
-          </a:p>
-          <a:p>
-            <a:pPr indent="0" marL="0">
-              <a:lnSpc>
-                <a:spcPts val="1800"/>
-              </a:lnSpc>
-              <a:buNone/>
-            </a:pPr>
-            <a:r>
-              <a:rPr lang="en-US" sz="1200" dirty="0">
-                <a:solidFill>
-                  <a:srgbClr val="334155"/>
-                </a:solidFill>
-                <a:latin typeface="Arial" pitchFamily="34" charset="0"/>
-                <a:ea typeface="Arial" pitchFamily="34" charset="-122"/>
-                <a:cs typeface="Arial" pitchFamily="34" charset="-120"/>
-              </a:rPr>
-              <a:t>Role: All Roles</a:t>
-            </a:r>
-            <a:endParaRPr lang="en-US" sz="1200" dirty="0"/>
-          </a:p>
-          <a:p>
-            <a:pPr indent="0" marL="0">
-              <a:lnSpc>
-                <a:spcPts val="1800"/>
-              </a:lnSpc>
-              <a:buNone/>
-            </a:pPr>
-            <a:r>
-              <a:rPr lang="en-US" sz="1200" dirty="0">
-                <a:solidFill>
-                  <a:srgbClr val="334155"/>
-                </a:solidFill>
-                <a:latin typeface="Arial" pitchFamily="34" charset="0"/>
-                <a:ea typeface="Arial" pitchFamily="34" charset="-122"/>
-                <a:cs typeface="Arial" pitchFamily="34" charset="-120"/>
-              </a:rPr>
-              <a:t>Path: /login (Mobile Viewport)</a:t>
-            </a:r>
-            <a:endParaRPr lang="en-US" sz="1200" dirty="0"/>
-          </a:p>
-          <a:p>
-            <a:pPr indent="0" marL="0">
-              <a:lnSpc>
-                <a:spcPts val="1800"/>
-              </a:lnSpc>
-              <a:buNone/>
-            </a:pPr>
-            <a:r>
-              <a:rPr lang="en-US" sz="1200" dirty="0">
-                <a:solidFill>
-                  <a:srgbClr val="334155"/>
-                </a:solidFill>
-                <a:latin typeface="Arial" pitchFamily="34" charset="0"/>
-                <a:ea typeface="Arial" pitchFamily="34" charset="-122"/>
-                <a:cs typeface="Arial" pitchFamily="34" charset="-120"/>
-              </a:rPr>
-              <a:t>Outcome: Flawless mobile entry and responsive redirection.</a:t>
-            </a:r>
-            <a:endParaRPr lang="en-US" sz="1200" dirty="0"/>
-          </a:p>
-        </p:txBody>
-      </p:sp>
-      <p:sp>
-        <p:nvSpPr>
-          <p:cNvPr id="7" name="Shape 5"/>
-          <p:cNvSpPr/>
-          <p:nvPr/>
-        </p:nvSpPr>
-        <p:spPr>
-          <a:xfrm>
-            <a:off x="5852160" y="1371600"/>
-            <a:ext cx="5760720" cy="4389120"/>
-          </a:xfrm>
-          <a:prstGeom prst="rect">
-            <a:avLst/>
-          </a:prstGeom>
-          <a:solidFill>
-            <a:srgbClr val="FFFFFF"/>
-          </a:solidFill>
-          <a:ln w="19050">
-            <a:solidFill>
-              <a:srgbClr val="CBD5E1"/>
-            </a:solidFill>
-            <a:prstDash val="solid"/>
-          </a:ln>
-        </p:spPr>
-      </p:sp>
-      <p:pic>
-        <p:nvPicPr>
-          <p:cNvPr id="8" name="Image 0" descr="D:\Desktop\quizhive _ lms\scratch\screenshots\31_mobile_home.png">    </p:cNvPr>
-          <p:cNvPicPr>
-            <a:picLocks noChangeAspect="1"/>
-          </p:cNvPicPr>
-          <p:nvPr/>
-        </p:nvPicPr>
-        <p:blipFill>
-          <a:blip r:embed="rId1"/>
-          <a:stretch>
-            <a:fillRect/>
-          </a:stretch>
-        </p:blipFill>
-        <p:spPr>
-          <a:xfrm>
-            <a:off x="5897880" y="1417320"/>
-            <a:ext cx="5669280" cy="4297680"/>
-          </a:xfrm>
-          <a:prstGeom prst="rect">
-            <a:avLst/>
-          </a:prstGeom>
-        </p:spPr>
-      </p:pic>
+              <a:t>State-of-the-art background communication keeps the team synchronized:</a:t>
+            </a:r>
+            <a:endParaRPr lang="en-US" sz="1200" dirty="0"/>
+          </a:p>
+          <a:p>
+            <a:pPr indent="0" marL="0">
+              <a:lnSpc>
+                <a:spcPts val="1800"/>
+              </a:lnSpc>
+              <a:buNone/>
+            </a:pPr>
+            <a:endParaRPr lang="en-US" sz="1200" dirty="0"/>
+          </a:p>
+          <a:p>
+            <a:pPr indent="0" marL="0">
+              <a:lnSpc>
+                <a:spcPts val="1800"/>
+              </a:lnSpc>
+              <a:buNone/>
+            </a:pPr>
+            <a:r>
+              <a:rPr lang="en-US" sz="1200" dirty="0">
+                <a:solidFill>
+                  <a:srgbClr val="334155"/>
+                </a:solidFill>
+                <a:latin typeface="Arial" pitchFamily="34" charset="0"/>
+                <a:ea typeface="Arial" pitchFamily="34" charset="-122"/>
+                <a:cs typeface="Arial" pitchFamily="34" charset="-120"/>
+              </a:rPr>
+              <a:t>• WebSocket Protocol: Establishes a bidirectional channel between the Express server and React client.</a:t>
+            </a:r>
+            <a:endParaRPr lang="en-US" sz="1200" dirty="0"/>
+          </a:p>
+          <a:p>
+            <a:pPr indent="0" marL="0">
+              <a:lnSpc>
+                <a:spcPts val="1800"/>
+              </a:lnSpc>
+              <a:buNone/>
+            </a:pPr>
+            <a:r>
+              <a:rPr lang="en-US" sz="1200" dirty="0">
+                <a:solidFill>
+                  <a:srgbClr val="334155"/>
+                </a:solidFill>
+                <a:latin typeface="Arial" pitchFamily="34" charset="0"/>
+                <a:ea typeface="Arial" pitchFamily="34" charset="-122"/>
+                <a:cs typeface="Arial" pitchFamily="34" charset="-120"/>
+              </a:rPr>
+              <a:t>• Background Refresh: Dashboards update silently in the background without affecting screen viewing.</a:t>
+            </a:r>
+            <a:endParaRPr lang="en-US" sz="1200" dirty="0"/>
+          </a:p>
+          <a:p>
+            <a:pPr indent="0" marL="0">
+              <a:lnSpc>
+                <a:spcPts val="1800"/>
+              </a:lnSpc>
+              <a:buNone/>
+            </a:pPr>
+            <a:r>
+              <a:rPr lang="en-US" sz="1200" dirty="0">
+                <a:solidFill>
+                  <a:srgbClr val="334155"/>
+                </a:solidFill>
+                <a:latin typeface="Arial" pitchFamily="34" charset="0"/>
+                <a:ea typeface="Arial" pitchFamily="34" charset="-122"/>
+                <a:cs typeface="Arial" pitchFamily="34" charset="-120"/>
+              </a:rPr>
+              <a:t>• Event-Driven: Triggers update calls on events like live_session_finished, offline_response_submitted, report_deleted.</a:t>
+            </a:r>
+            <a:endParaRPr lang="en-US" sz="1200" dirty="0"/>
+          </a:p>
+        </p:txBody>
+      </p:sp>
     </p:spTree>
   </p:cSld>
   <p:clrMapOvr>
@@ -12686,7 +12787,7 @@
                 <a:ea typeface="Arial" pitchFamily="34" charset="-122"/>
                 <a:cs typeface="Arial" pitchFamily="34" charset="-120"/>
               </a:rPr>
-              <a:t>Mobile Learner Portal &amp; Quiz Join</a:t>
+              <a:t>Mobile Interface Design &amp; Sign-In</a:t>
             </a:r>
             <a:endParaRPr lang="en-US" sz="2400" dirty="0"/>
           </a:p>
@@ -12800,127 +12901,127 @@
                 <a:ea typeface="Arial" pitchFamily="34" charset="-122"/>
                 <a:cs typeface="Arial" pitchFamily="34" charset="-120"/>
               </a:rPr>
-              <a:t>Screen Name: Mobile Join Page</a:t>
-            </a:r>
-            <a:endParaRPr lang="en-US" sz="1200" dirty="0"/>
-          </a:p>
-          <a:p>
-            <a:pPr indent="0" marL="0">
-              <a:lnSpc>
-                <a:spcPts val="1800"/>
-              </a:lnSpc>
-              <a:buNone/>
-            </a:pPr>
-            <a:r>
-              <a:rPr lang="en-US" sz="1200" dirty="0">
-                <a:solidFill>
-                  <a:srgbClr val="334155"/>
-                </a:solidFill>
-                <a:latin typeface="Arial" pitchFamily="34" charset="0"/>
-                <a:ea typeface="Arial" pitchFamily="34" charset="-122"/>
-                <a:cs typeface="Arial" pitchFamily="34" charset="-120"/>
-              </a:rPr>
-              <a:t>Purpose: Mobile-first interface for promoters to enter live sessions.</a:t>
-            </a:r>
-            <a:endParaRPr lang="en-US" sz="1200" dirty="0"/>
-          </a:p>
-          <a:p>
-            <a:pPr indent="0" marL="0">
-              <a:lnSpc>
-                <a:spcPts val="1800"/>
-              </a:lnSpc>
-              <a:buNone/>
-            </a:pPr>
-            <a:r>
-              <a:rPr lang="en-US" sz="1200" dirty="0">
-                <a:solidFill>
-                  <a:srgbClr val="334155"/>
-                </a:solidFill>
-                <a:latin typeface="Arial" pitchFamily="34" charset="0"/>
-                <a:ea typeface="Arial" pitchFamily="34" charset="-122"/>
-                <a:cs typeface="Arial" pitchFamily="34" charset="-120"/>
-              </a:rPr>
-              <a:t>Features: Room code input field, quick-join buttons, latest offline quizzes download center.</a:t>
-            </a:r>
-            <a:endParaRPr lang="en-US" sz="1200" dirty="0"/>
-          </a:p>
-          <a:p>
-            <a:pPr indent="0" marL="0">
-              <a:lnSpc>
-                <a:spcPts val="1800"/>
-              </a:lnSpc>
-              <a:buNone/>
-            </a:pPr>
-            <a:r>
-              <a:rPr lang="en-US" sz="1200" dirty="0">
-                <a:solidFill>
-                  <a:srgbClr val="334155"/>
-                </a:solidFill>
-                <a:latin typeface="Arial" pitchFamily="34" charset="0"/>
-                <a:ea typeface="Arial" pitchFamily="34" charset="-122"/>
-                <a:cs typeface="Arial" pitchFamily="34" charset="-120"/>
-              </a:rPr>
-              <a:t>Benefits: Simplifies the joining workflow—promoters enter the arena in under 5 seconds.</a:t>
-            </a:r>
-            <a:endParaRPr lang="en-US" sz="1200" dirty="0"/>
-          </a:p>
-          <a:p>
-            <a:pPr indent="0" marL="0">
-              <a:lnSpc>
-                <a:spcPts val="1800"/>
-              </a:lnSpc>
-              <a:buNone/>
-            </a:pPr>
-            <a:r>
-              <a:rPr lang="en-US" sz="1200" dirty="0">
-                <a:solidFill>
-                  <a:srgbClr val="334155"/>
-                </a:solidFill>
-                <a:latin typeface="Arial" pitchFamily="34" charset="0"/>
-                <a:ea typeface="Arial" pitchFamily="34" charset="-122"/>
-                <a:cs typeface="Arial" pitchFamily="34" charset="-120"/>
-              </a:rPr>
-              <a:t>Role: Employee / Promoters</a:t>
-            </a:r>
-            <a:endParaRPr lang="en-US" sz="1200" dirty="0"/>
-          </a:p>
-          <a:p>
-            <a:pPr indent="0" marL="0">
-              <a:lnSpc>
-                <a:spcPts val="1800"/>
-              </a:lnSpc>
-              <a:buNone/>
-            </a:pPr>
-            <a:r>
-              <a:rPr lang="en-US" sz="1200" dirty="0">
-                <a:solidFill>
-                  <a:srgbClr val="334155"/>
-                </a:solidFill>
-                <a:latin typeface="Arial" pitchFamily="34" charset="0"/>
-                <a:ea typeface="Arial" pitchFamily="34" charset="-122"/>
-                <a:cs typeface="Arial" pitchFamily="34" charset="-120"/>
-              </a:rPr>
-              <a:t>Path: /join (Mobile Viewport)</a:t>
-            </a:r>
-            <a:endParaRPr lang="en-US" sz="1200" dirty="0"/>
-          </a:p>
-          <a:p>
-            <a:pPr indent="0" marL="0">
-              <a:lnSpc>
-                <a:spcPts val="1800"/>
-              </a:lnSpc>
-              <a:buNone/>
-            </a:pPr>
-            <a:r>
-              <a:rPr lang="en-US" sz="1200" dirty="0">
-                <a:solidFill>
-                  <a:srgbClr val="334155"/>
-                </a:solidFill>
-                <a:latin typeface="Arial" pitchFamily="34" charset="0"/>
-                <a:ea typeface="Arial" pitchFamily="34" charset="-122"/>
-                <a:cs typeface="Arial" pitchFamily="34" charset="-120"/>
-              </a:rPr>
-              <a:t>Outcome: Direct access to active evaluations on the store floor.</a:t>
+              <a:t>Screen Name: Mobile Login Page</a:t>
+            </a:r>
+            <a:endParaRPr lang="en-US" sz="1200" dirty="0"/>
+          </a:p>
+          <a:p>
+            <a:pPr indent="0" marL="0">
+              <a:lnSpc>
+                <a:spcPts val="1800"/>
+              </a:lnSpc>
+              <a:buNone/>
+            </a:pPr>
+            <a:r>
+              <a:rPr lang="en-US" sz="1200" dirty="0">
+                <a:solidFill>
+                  <a:srgbClr val="334155"/>
+                </a:solidFill>
+                <a:latin typeface="Arial" pitchFamily="34" charset="0"/>
+                <a:ea typeface="Arial" pitchFamily="34" charset="-122"/>
+                <a:cs typeface="Arial" pitchFamily="34" charset="-120"/>
+              </a:rPr>
+              <a:t>Purpose: Portal access for field staff using mobile devices.</a:t>
+            </a:r>
+            <a:endParaRPr lang="en-US" sz="1200" dirty="0"/>
+          </a:p>
+          <a:p>
+            <a:pPr indent="0" marL="0">
+              <a:lnSpc>
+                <a:spcPts val="1800"/>
+              </a:lnSpc>
+              <a:buNone/>
+            </a:pPr>
+            <a:r>
+              <a:rPr lang="en-US" sz="1200" dirty="0">
+                <a:solidFill>
+                  <a:srgbClr val="334155"/>
+                </a:solidFill>
+                <a:latin typeface="Arial" pitchFamily="34" charset="0"/>
+                <a:ea typeface="Arial" pitchFamily="34" charset="-122"/>
+                <a:cs typeface="Arial" pitchFamily="34" charset="-120"/>
+              </a:rPr>
+              <a:t>Features: Responsive form fields, quick-tap inputs, low-data asset sizes, MASCOT tips overlay.</a:t>
+            </a:r>
+            <a:endParaRPr lang="en-US" sz="1200" dirty="0"/>
+          </a:p>
+          <a:p>
+            <a:pPr indent="0" marL="0">
+              <a:lnSpc>
+                <a:spcPts val="1800"/>
+              </a:lnSpc>
+              <a:buNone/>
+            </a:pPr>
+            <a:r>
+              <a:rPr lang="en-US" sz="1200" dirty="0">
+                <a:solidFill>
+                  <a:srgbClr val="334155"/>
+                </a:solidFill>
+                <a:latin typeface="Arial" pitchFamily="34" charset="0"/>
+                <a:ea typeface="Arial" pitchFamily="34" charset="-122"/>
+                <a:cs typeface="Arial" pitchFamily="34" charset="-120"/>
+              </a:rPr>
+              <a:t>Benefits: Smooth user experience on low-end Android smartphones; minimal bandwidth usage.</a:t>
+            </a:r>
+            <a:endParaRPr lang="en-US" sz="1200" dirty="0"/>
+          </a:p>
+          <a:p>
+            <a:pPr indent="0" marL="0">
+              <a:lnSpc>
+                <a:spcPts val="1800"/>
+              </a:lnSpc>
+              <a:buNone/>
+            </a:pPr>
+            <a:r>
+              <a:rPr lang="en-US" sz="1200" dirty="0">
+                <a:solidFill>
+                  <a:srgbClr val="334155"/>
+                </a:solidFill>
+                <a:latin typeface="Arial" pitchFamily="34" charset="0"/>
+                <a:ea typeface="Arial" pitchFamily="34" charset="-122"/>
+                <a:cs typeface="Arial" pitchFamily="34" charset="-120"/>
+              </a:rPr>
+              <a:t>Role: All Roles</a:t>
+            </a:r>
+            <a:endParaRPr lang="en-US" sz="1200" dirty="0"/>
+          </a:p>
+          <a:p>
+            <a:pPr indent="0" marL="0">
+              <a:lnSpc>
+                <a:spcPts val="1800"/>
+              </a:lnSpc>
+              <a:buNone/>
+            </a:pPr>
+            <a:r>
+              <a:rPr lang="en-US" sz="1200" dirty="0">
+                <a:solidFill>
+                  <a:srgbClr val="334155"/>
+                </a:solidFill>
+                <a:latin typeface="Arial" pitchFamily="34" charset="0"/>
+                <a:ea typeface="Arial" pitchFamily="34" charset="-122"/>
+                <a:cs typeface="Arial" pitchFamily="34" charset="-120"/>
+              </a:rPr>
+              <a:t>Path: /login (Mobile Viewport)</a:t>
+            </a:r>
+            <a:endParaRPr lang="en-US" sz="1200" dirty="0"/>
+          </a:p>
+          <a:p>
+            <a:pPr indent="0" marL="0">
+              <a:lnSpc>
+                <a:spcPts val="1800"/>
+              </a:lnSpc>
+              <a:buNone/>
+            </a:pPr>
+            <a:r>
+              <a:rPr lang="en-US" sz="1200" dirty="0">
+                <a:solidFill>
+                  <a:srgbClr val="334155"/>
+                </a:solidFill>
+                <a:latin typeface="Arial" pitchFamily="34" charset="0"/>
+                <a:ea typeface="Arial" pitchFamily="34" charset="-122"/>
+                <a:cs typeface="Arial" pitchFamily="34" charset="-120"/>
+              </a:rPr>
+              <a:t>Outcome: Flawless mobile entry and responsive redirection.</a:t>
             </a:r>
             <a:endParaRPr lang="en-US" sz="1200" dirty="0"/>
           </a:p>
@@ -12953,7 +13054,7 @@
       </p:sp>
       <p:pic>
         <p:nvPicPr>
-          <p:cNvPr id="8" name="Image 0" descr="D:\Desktop\quizhive _ lms\scratch\screenshots\32_mobile_learner_dashboard.png">    </p:cNvPr>
+          <p:cNvPr id="8" name="Image 0" descr="D:\Desktop\quizhive _ lms\scratch\screenshots\31_mobile_home.png">    </p:cNvPr>
           <p:cNvPicPr>
             <a:picLocks noChangeAspect="1"/>
           </p:cNvPicPr>
@@ -13079,7 +13180,7 @@
                 <a:ea typeface="Arial" pitchFamily="34" charset="-122"/>
                 <a:cs typeface="Arial" pitchFamily="34" charset="-120"/>
               </a:rPr>
-              <a:t>Mobile Live Quiz Gameplay Interface</a:t>
+              <a:t>Mobile Learner Portal &amp; Quiz Join</a:t>
             </a:r>
             <a:endParaRPr lang="en-US" sz="2400" dirty="0"/>
           </a:p>
@@ -13193,67 +13294,67 @@
                 <a:ea typeface="Arial" pitchFamily="34" charset="-122"/>
                 <a:cs typeface="Arial" pitchFamily="34" charset="-120"/>
               </a:rPr>
-              <a:t>Screen Name: Live Quiz Gameplay</a:t>
-            </a:r>
-            <a:endParaRPr lang="en-US" sz="1200" dirty="0"/>
-          </a:p>
-          <a:p>
-            <a:pPr indent="0" marL="0">
-              <a:lnSpc>
-                <a:spcPts val="1800"/>
-              </a:lnSpc>
-              <a:buNone/>
-            </a:pPr>
-            <a:r>
-              <a:rPr lang="en-US" sz="1200" dirty="0">
-                <a:solidFill>
-                  <a:srgbClr val="334155"/>
-                </a:solidFill>
-                <a:latin typeface="Arial" pitchFamily="34" charset="0"/>
-                <a:ea typeface="Arial" pitchFamily="34" charset="-122"/>
-                <a:cs typeface="Arial" pitchFamily="34" charset="-120"/>
-              </a:rPr>
-              <a:t>Purpose: Mobile interface for answering live assessment items.</a:t>
-            </a:r>
-            <a:endParaRPr lang="en-US" sz="1200" dirty="0"/>
-          </a:p>
-          <a:p>
-            <a:pPr indent="0" marL="0">
-              <a:lnSpc>
-                <a:spcPts val="1800"/>
-              </a:lnSpc>
-              <a:buNone/>
-            </a:pPr>
-            <a:r>
-              <a:rPr lang="en-US" sz="1200" dirty="0">
-                <a:solidFill>
-                  <a:srgbClr val="334155"/>
-                </a:solidFill>
-                <a:latin typeface="Arial" pitchFamily="34" charset="0"/>
-                <a:ea typeface="Arial" pitchFamily="34" charset="-122"/>
-                <a:cs typeface="Arial" pitchFamily="34" charset="-120"/>
-              </a:rPr>
-              <a:t>Features: Large tap-friendly option blocks, real-time timer countdown, immediate correct/incorrect feedback.</a:t>
-            </a:r>
-            <a:endParaRPr lang="en-US" sz="1200" dirty="0"/>
-          </a:p>
-          <a:p>
-            <a:pPr indent="0" marL="0">
-              <a:lnSpc>
-                <a:spcPts val="1800"/>
-              </a:lnSpc>
-              <a:buNone/>
-            </a:pPr>
-            <a:r>
-              <a:rPr lang="en-US" sz="1200" dirty="0">
-                <a:solidFill>
-                  <a:srgbClr val="334155"/>
-                </a:solidFill>
-                <a:latin typeface="Arial" pitchFamily="34" charset="0"/>
-                <a:ea typeface="Arial" pitchFamily="34" charset="-122"/>
-                <a:cs typeface="Arial" pitchFamily="34" charset="-120"/>
-              </a:rPr>
-              <a:t>Benefits: Minimizes mistaps and provides immediate learning reinforcement on the floor.</a:t>
+              <a:t>Screen Name: Mobile Join Page</a:t>
+            </a:r>
+            <a:endParaRPr lang="en-US" sz="1200" dirty="0"/>
+          </a:p>
+          <a:p>
+            <a:pPr indent="0" marL="0">
+              <a:lnSpc>
+                <a:spcPts val="1800"/>
+              </a:lnSpc>
+              <a:buNone/>
+            </a:pPr>
+            <a:r>
+              <a:rPr lang="en-US" sz="1200" dirty="0">
+                <a:solidFill>
+                  <a:srgbClr val="334155"/>
+                </a:solidFill>
+                <a:latin typeface="Arial" pitchFamily="34" charset="0"/>
+                <a:ea typeface="Arial" pitchFamily="34" charset="-122"/>
+                <a:cs typeface="Arial" pitchFamily="34" charset="-120"/>
+              </a:rPr>
+              <a:t>Purpose: Mobile-first interface for promoters to enter live sessions.</a:t>
+            </a:r>
+            <a:endParaRPr lang="en-US" sz="1200" dirty="0"/>
+          </a:p>
+          <a:p>
+            <a:pPr indent="0" marL="0">
+              <a:lnSpc>
+                <a:spcPts val="1800"/>
+              </a:lnSpc>
+              <a:buNone/>
+            </a:pPr>
+            <a:r>
+              <a:rPr lang="en-US" sz="1200" dirty="0">
+                <a:solidFill>
+                  <a:srgbClr val="334155"/>
+                </a:solidFill>
+                <a:latin typeface="Arial" pitchFamily="34" charset="0"/>
+                <a:ea typeface="Arial" pitchFamily="34" charset="-122"/>
+                <a:cs typeface="Arial" pitchFamily="34" charset="-120"/>
+              </a:rPr>
+              <a:t>Features: Room code input field, quick-join buttons, latest offline quizzes download center.</a:t>
+            </a:r>
+            <a:endParaRPr lang="en-US" sz="1200" dirty="0"/>
+          </a:p>
+          <a:p>
+            <a:pPr indent="0" marL="0">
+              <a:lnSpc>
+                <a:spcPts val="1800"/>
+              </a:lnSpc>
+              <a:buNone/>
+            </a:pPr>
+            <a:r>
+              <a:rPr lang="en-US" sz="1200" dirty="0">
+                <a:solidFill>
+                  <a:srgbClr val="334155"/>
+                </a:solidFill>
+                <a:latin typeface="Arial" pitchFamily="34" charset="0"/>
+                <a:ea typeface="Arial" pitchFamily="34" charset="-122"/>
+                <a:cs typeface="Arial" pitchFamily="34" charset="-120"/>
+              </a:rPr>
+              <a:t>Benefits: Simplifies the joining workflow—promoters enter the arena in under 5 seconds.</a:t>
             </a:r>
             <a:endParaRPr lang="en-US" sz="1200" dirty="0"/>
           </a:p>
@@ -13293,27 +13394,27 @@
                 <a:ea typeface="Arial" pitchFamily="34" charset="-122"/>
                 <a:cs typeface="Arial" pitchFamily="34" charset="-120"/>
               </a:rPr>
-              <a:t>Path: /live/:roomCode (Mobile Viewport)</a:t>
-            </a:r>
-            <a:endParaRPr lang="en-US" sz="1200" dirty="0"/>
-          </a:p>
-          <a:p>
-            <a:pPr indent="0" marL="0">
-              <a:lnSpc>
-                <a:spcPts val="1800"/>
-              </a:lnSpc>
-              <a:buNone/>
-            </a:pPr>
-            <a:r>
-              <a:rPr lang="en-US" sz="1200" dirty="0">
-                <a:solidFill>
-                  <a:srgbClr val="334155"/>
-                </a:solidFill>
-                <a:latin typeface="Arial" pitchFamily="34" charset="0"/>
-                <a:ea typeface="Arial" pitchFamily="34" charset="-122"/>
-                <a:cs typeface="Arial" pitchFamily="34" charset="-120"/>
-              </a:rPr>
-              <a:t>Outcome: Dynamic audience participation and high training engagement.</a:t>
+              <a:t>Path: /join (Mobile Viewport)</a:t>
+            </a:r>
+            <a:endParaRPr lang="en-US" sz="1200" dirty="0"/>
+          </a:p>
+          <a:p>
+            <a:pPr indent="0" marL="0">
+              <a:lnSpc>
+                <a:spcPts val="1800"/>
+              </a:lnSpc>
+              <a:buNone/>
+            </a:pPr>
+            <a:r>
+              <a:rPr lang="en-US" sz="1200" dirty="0">
+                <a:solidFill>
+                  <a:srgbClr val="334155"/>
+                </a:solidFill>
+                <a:latin typeface="Arial" pitchFamily="34" charset="0"/>
+                <a:ea typeface="Arial" pitchFamily="34" charset="-122"/>
+                <a:cs typeface="Arial" pitchFamily="34" charset="-120"/>
+              </a:rPr>
+              <a:t>Outcome: Direct access to active evaluations on the store floor.</a:t>
             </a:r>
             <a:endParaRPr lang="en-US" sz="1200" dirty="0"/>
           </a:p>
@@ -13346,7 +13447,7 @@
       </p:sp>
       <p:pic>
         <p:nvPicPr>
-          <p:cNvPr id="8" name="Image 0" descr="D:\Desktop\quizhive _ lms\scratch\screenshots\33_mobile_live_quiz.png">    </p:cNvPr>
+          <p:cNvPr id="8" name="Image 0" descr="D:\Desktop\quizhive _ lms\scratch\screenshots\32_mobile_learner_dashboard.png">    </p:cNvPr>
           <p:cNvPicPr>
             <a:picLocks noChangeAspect="1"/>
           </p:cNvPicPr>
@@ -13433,7 +13534,7 @@
                 <a:ea typeface="Arial" pitchFamily="34" charset="-122"/>
                 <a:cs typeface="Arial" pitchFamily="34" charset="-120"/>
               </a:rPr>
-              <a:t>BUSINESS VALUE &amp; ROI</a:t>
+              <a:t>MOBILE UI &amp; PORTALS</a:t>
             </a:r>
             <a:endParaRPr lang="en-US" sz="1000" dirty="0"/>
           </a:p>
@@ -13472,7 +13573,7 @@
                 <a:ea typeface="Arial" pitchFamily="34" charset="-122"/>
                 <a:cs typeface="Arial" pitchFamily="34" charset="-120"/>
               </a:rPr>
-              <a:t>Retail Campaign Alignment &amp; ROI</a:t>
+              <a:t>Mobile Live Quiz Gameplay Interface</a:t>
             </a:r>
             <a:endParaRPr lang="en-US" sz="2400" dirty="0"/>
           </a:p>
@@ -13586,81 +13687,181 @@
                 <a:ea typeface="Arial" pitchFamily="34" charset="-122"/>
                 <a:cs typeface="Arial" pitchFamily="34" charset="-120"/>
               </a:rPr>
-              <a:t>Align frontline training with marketing and campaign rollouts:</a:t>
-            </a:r>
-            <a:endParaRPr lang="en-US" sz="1200" dirty="0"/>
-          </a:p>
-          <a:p>
-            <a:pPr indent="0" marL="0">
-              <a:lnSpc>
-                <a:spcPts val="1800"/>
-              </a:lnSpc>
-              <a:buNone/>
-            </a:pPr>
-            <a:endParaRPr lang="en-US" sz="1200" dirty="0"/>
-          </a:p>
-          <a:p>
-            <a:pPr indent="0" marL="0">
-              <a:lnSpc>
-                <a:spcPts val="1800"/>
-              </a:lnSpc>
-              <a:buNone/>
-            </a:pPr>
-            <a:r>
-              <a:rPr lang="en-US" sz="1200" dirty="0">
-                <a:solidFill>
-                  <a:srgbClr val="334155"/>
-                </a:solidFill>
-                <a:latin typeface="Arial" pitchFamily="34" charset="0"/>
-                <a:ea typeface="Arial" pitchFamily="34" charset="-122"/>
-                <a:cs typeface="Arial" pitchFamily="34" charset="-120"/>
-              </a:rPr>
-              <a:t>• Speed to Floor: Deploy new product guidelines to 1000+ promoters in under an hour.</a:t>
-            </a:r>
-            <a:endParaRPr lang="en-US" sz="1200" dirty="0"/>
-          </a:p>
-          <a:p>
-            <a:pPr indent="0" marL="0">
-              <a:lnSpc>
-                <a:spcPts val="1800"/>
-              </a:lnSpc>
-              <a:buNone/>
-            </a:pPr>
-            <a:r>
-              <a:rPr lang="en-US" sz="1200" dirty="0">
-                <a:solidFill>
-                  <a:srgbClr val="334155"/>
-                </a:solidFill>
-                <a:latin typeface="Arial" pitchFamily="34" charset="0"/>
-                <a:ea typeface="Arial" pitchFamily="34" charset="-122"/>
-                <a:cs typeface="Arial" pitchFamily="34" charset="-120"/>
-              </a:rPr>
-              <a:t>• Compliance Auditing: Verify that promoter knowledge matches the target display guidelines.</a:t>
-            </a:r>
-            <a:endParaRPr lang="en-US" sz="1200" dirty="0"/>
-          </a:p>
-          <a:p>
-            <a:pPr indent="0" marL="0">
-              <a:lnSpc>
-                <a:spcPts val="1800"/>
-              </a:lnSpc>
-              <a:buNone/>
-            </a:pPr>
-            <a:r>
-              <a:rPr lang="en-US" sz="1200" dirty="0">
-                <a:solidFill>
-                  <a:srgbClr val="334155"/>
-                </a:solidFill>
-                <a:latin typeface="Arial" pitchFamily="34" charset="0"/>
-                <a:ea typeface="Arial" pitchFamily="34" charset="-122"/>
-                <a:cs typeface="Arial" pitchFamily="34" charset="-120"/>
-              </a:rPr>
-              <a:t>• ROI Metrics: Proven reduction in training costs by 45% compared to on-site trainer visits.</a:t>
-            </a:r>
-            <a:endParaRPr lang="en-US" sz="1200" dirty="0"/>
-          </a:p>
-        </p:txBody>
-      </p:sp>
+              <a:t>Screen Name: Live Quiz Gameplay</a:t>
+            </a:r>
+            <a:endParaRPr lang="en-US" sz="1200" dirty="0"/>
+          </a:p>
+          <a:p>
+            <a:pPr indent="0" marL="0">
+              <a:lnSpc>
+                <a:spcPts val="1800"/>
+              </a:lnSpc>
+              <a:buNone/>
+            </a:pPr>
+            <a:r>
+              <a:rPr lang="en-US" sz="1200" dirty="0">
+                <a:solidFill>
+                  <a:srgbClr val="334155"/>
+                </a:solidFill>
+                <a:latin typeface="Arial" pitchFamily="34" charset="0"/>
+                <a:ea typeface="Arial" pitchFamily="34" charset="-122"/>
+                <a:cs typeface="Arial" pitchFamily="34" charset="-120"/>
+              </a:rPr>
+              <a:t>Purpose: Mobile interface for answering live assessment items.</a:t>
+            </a:r>
+            <a:endParaRPr lang="en-US" sz="1200" dirty="0"/>
+          </a:p>
+          <a:p>
+            <a:pPr indent="0" marL="0">
+              <a:lnSpc>
+                <a:spcPts val="1800"/>
+              </a:lnSpc>
+              <a:buNone/>
+            </a:pPr>
+            <a:r>
+              <a:rPr lang="en-US" sz="1200" dirty="0">
+                <a:solidFill>
+                  <a:srgbClr val="334155"/>
+                </a:solidFill>
+                <a:latin typeface="Arial" pitchFamily="34" charset="0"/>
+                <a:ea typeface="Arial" pitchFamily="34" charset="-122"/>
+                <a:cs typeface="Arial" pitchFamily="34" charset="-120"/>
+              </a:rPr>
+              <a:t>Features: Large tap-friendly option blocks, real-time timer countdown, immediate correct/incorrect feedback.</a:t>
+            </a:r>
+            <a:endParaRPr lang="en-US" sz="1200" dirty="0"/>
+          </a:p>
+          <a:p>
+            <a:pPr indent="0" marL="0">
+              <a:lnSpc>
+                <a:spcPts val="1800"/>
+              </a:lnSpc>
+              <a:buNone/>
+            </a:pPr>
+            <a:r>
+              <a:rPr lang="en-US" sz="1200" dirty="0">
+                <a:solidFill>
+                  <a:srgbClr val="334155"/>
+                </a:solidFill>
+                <a:latin typeface="Arial" pitchFamily="34" charset="0"/>
+                <a:ea typeface="Arial" pitchFamily="34" charset="-122"/>
+                <a:cs typeface="Arial" pitchFamily="34" charset="-120"/>
+              </a:rPr>
+              <a:t>Benefits: Minimizes mistaps and provides immediate learning reinforcement on the floor.</a:t>
+            </a:r>
+            <a:endParaRPr lang="en-US" sz="1200" dirty="0"/>
+          </a:p>
+          <a:p>
+            <a:pPr indent="0" marL="0">
+              <a:lnSpc>
+                <a:spcPts val="1800"/>
+              </a:lnSpc>
+              <a:buNone/>
+            </a:pPr>
+            <a:r>
+              <a:rPr lang="en-US" sz="1200" dirty="0">
+                <a:solidFill>
+                  <a:srgbClr val="334155"/>
+                </a:solidFill>
+                <a:latin typeface="Arial" pitchFamily="34" charset="0"/>
+                <a:ea typeface="Arial" pitchFamily="34" charset="-122"/>
+                <a:cs typeface="Arial" pitchFamily="34" charset="-120"/>
+              </a:rPr>
+              <a:t>Role: Employee / Promoters</a:t>
+            </a:r>
+            <a:endParaRPr lang="en-US" sz="1200" dirty="0"/>
+          </a:p>
+          <a:p>
+            <a:pPr indent="0" marL="0">
+              <a:lnSpc>
+                <a:spcPts val="1800"/>
+              </a:lnSpc>
+              <a:buNone/>
+            </a:pPr>
+            <a:r>
+              <a:rPr lang="en-US" sz="1200" dirty="0">
+                <a:solidFill>
+                  <a:srgbClr val="334155"/>
+                </a:solidFill>
+                <a:latin typeface="Arial" pitchFamily="34" charset="0"/>
+                <a:ea typeface="Arial" pitchFamily="34" charset="-122"/>
+                <a:cs typeface="Arial" pitchFamily="34" charset="-120"/>
+              </a:rPr>
+              <a:t>Path: /live/:roomCode (Mobile Viewport)</a:t>
+            </a:r>
+            <a:endParaRPr lang="en-US" sz="1200" dirty="0"/>
+          </a:p>
+          <a:p>
+            <a:pPr indent="0" marL="0">
+              <a:lnSpc>
+                <a:spcPts val="1800"/>
+              </a:lnSpc>
+              <a:buNone/>
+            </a:pPr>
+            <a:r>
+              <a:rPr lang="en-US" sz="1200" dirty="0">
+                <a:solidFill>
+                  <a:srgbClr val="334155"/>
+                </a:solidFill>
+                <a:latin typeface="Arial" pitchFamily="34" charset="0"/>
+                <a:ea typeface="Arial" pitchFamily="34" charset="-122"/>
+                <a:cs typeface="Arial" pitchFamily="34" charset="-120"/>
+              </a:rPr>
+              <a:t>Outcome: Dynamic audience participation and high training engagement.</a:t>
+            </a:r>
+            <a:endParaRPr lang="en-US" sz="1200" dirty="0"/>
+          </a:p>
+        </p:txBody>
+      </p:sp>
+      <p:sp>
+        <p:nvSpPr>
+          <p:cNvPr id="7" name="Shape 5"/>
+          <p:cNvSpPr/>
+          <p:nvPr/>
+        </p:nvSpPr>
+        <p:spPr>
+          <a:xfrm>
+            <a:off x="5852160" y="1371600"/>
+            <a:ext cx="5760720" cy="4389120"/>
+          </a:xfrm>
+          <a:prstGeom prst="rect">
+            <a:avLst/>
+          </a:prstGeom>
+          <a:solidFill>
+            <a:srgbClr val="FFFFFF"/>
+          </a:solidFill>
+          <a:ln w="19050">
+            <a:solidFill>
+              <a:srgbClr val="CBD5E1"/>
+            </a:solidFill>
+            <a:prstDash val="solid"/>
+          </a:ln>
+        </p:spPr>
+      </p:sp>
+      <p:pic>
+        <p:nvPicPr>
+          <p:cNvPr id="8" name="Image 0" descr="D:\Desktop\quizhive _ lms\scratch\screenshots\33_mobile_live_quiz.png">    </p:cNvPr>
+          <p:cNvPicPr>
+            <a:picLocks noChangeAspect="1"/>
+          </p:cNvPicPr>
+          <p:nvPr/>
+        </p:nvPicPr>
+        <p:blipFill>
+          <a:blip r:embed="rId1"/>
+          <a:stretch>
+            <a:fillRect/>
+          </a:stretch>
+        </p:blipFill>
+        <p:spPr>
+          <a:xfrm>
+            <a:off x="5897880" y="1417320"/>
+            <a:ext cx="5669280" cy="4297680"/>
+          </a:xfrm>
+          <a:prstGeom prst="rect">
+            <a:avLst/>
+          </a:prstGeom>
+        </p:spPr>
+      </p:pic>
     </p:spTree>
   </p:cSld>
   <p:clrMapOvr>
@@ -13765,7 +13966,7 @@
                 <a:ea typeface="Arial" pitchFamily="34" charset="-122"/>
                 <a:cs typeface="Arial" pitchFamily="34" charset="-120"/>
               </a:rPr>
-              <a:t>Frontline Compliance Verification</a:t>
+              <a:t>Retail Campaign Alignment &amp; ROI</a:t>
             </a:r>
             <a:endParaRPr lang="en-US" sz="2400" dirty="0"/>
           </a:p>
@@ -13879,76 +14080,76 @@
                 <a:ea typeface="Arial" pitchFamily="34" charset="-122"/>
                 <a:cs typeface="Arial" pitchFamily="34" charset="-120"/>
               </a:rPr>
-              <a:t>Verify store execution guidelines and SOP adherence:</a:t>
-            </a:r>
-            <a:endParaRPr lang="en-US" sz="1200" dirty="0"/>
-          </a:p>
-          <a:p>
-            <a:pPr indent="0" marL="0">
-              <a:lnSpc>
-                <a:spcPts val="1800"/>
-              </a:lnSpc>
-              <a:buNone/>
-            </a:pPr>
-            <a:endParaRPr lang="en-US" sz="1200" dirty="0"/>
-          </a:p>
-          <a:p>
-            <a:pPr indent="0" marL="0">
-              <a:lnSpc>
-                <a:spcPts val="1800"/>
-              </a:lnSpc>
-              <a:buNone/>
-            </a:pPr>
-            <a:r>
-              <a:rPr lang="en-US" sz="1200" dirty="0">
-                <a:solidFill>
-                  <a:srgbClr val="334155"/>
-                </a:solidFill>
-                <a:latin typeface="Arial" pitchFamily="34" charset="0"/>
-                <a:ea typeface="Arial" pitchFamily="34" charset="-122"/>
-                <a:cs typeface="Arial" pitchFamily="34" charset="-120"/>
-              </a:rPr>
-              <a:t>• Audit Logs: Automated timestamps capture when a promoter completes standard training.</a:t>
-            </a:r>
-            <a:endParaRPr lang="en-US" sz="1200" dirty="0"/>
-          </a:p>
-          <a:p>
-            <a:pPr indent="0" marL="0">
-              <a:lnSpc>
-                <a:spcPts val="1800"/>
-              </a:lnSpc>
-              <a:buNone/>
-            </a:pPr>
-            <a:r>
-              <a:rPr lang="en-US" sz="1200" dirty="0">
-                <a:solidFill>
-                  <a:srgbClr val="334155"/>
-                </a:solidFill>
-                <a:latin typeface="Arial" pitchFamily="34" charset="0"/>
-                <a:ea typeface="Arial" pitchFamily="34" charset="-122"/>
-                <a:cs typeface="Arial" pitchFamily="34" charset="-120"/>
-              </a:rPr>
-              <a:t>• Error Flags: Instantly alerts supervisors when store accuracy falls below the 60% threshold.</a:t>
-            </a:r>
-            <a:endParaRPr lang="en-US" sz="1200" dirty="0"/>
-          </a:p>
-          <a:p>
-            <a:pPr indent="0" marL="0">
-              <a:lnSpc>
-                <a:spcPts val="1800"/>
-              </a:lnSpc>
-              <a:buNone/>
-            </a:pPr>
-            <a:r>
-              <a:rPr lang="en-US" sz="1200" dirty="0">
-                <a:solidFill>
-                  <a:srgbClr val="334155"/>
-                </a:solidFill>
-                <a:latin typeface="Arial" pitchFamily="34" charset="0"/>
-                <a:ea typeface="Arial" pitchFamily="34" charset="-122"/>
-                <a:cs typeface="Arial" pitchFamily="34" charset="-120"/>
-              </a:rPr>
-              <a:t>• Actionable Insights: Reports detail exact question options selected, identifying specific confusion points.</a:t>
+              <a:t>Align frontline training with marketing and campaign rollouts:</a:t>
+            </a:r>
+            <a:endParaRPr lang="en-US" sz="1200" dirty="0"/>
+          </a:p>
+          <a:p>
+            <a:pPr indent="0" marL="0">
+              <a:lnSpc>
+                <a:spcPts val="1800"/>
+              </a:lnSpc>
+              <a:buNone/>
+            </a:pPr>
+            <a:endParaRPr lang="en-US" sz="1200" dirty="0"/>
+          </a:p>
+          <a:p>
+            <a:pPr indent="0" marL="0">
+              <a:lnSpc>
+                <a:spcPts val="1800"/>
+              </a:lnSpc>
+              <a:buNone/>
+            </a:pPr>
+            <a:r>
+              <a:rPr lang="en-US" sz="1200" dirty="0">
+                <a:solidFill>
+                  <a:srgbClr val="334155"/>
+                </a:solidFill>
+                <a:latin typeface="Arial" pitchFamily="34" charset="0"/>
+                <a:ea typeface="Arial" pitchFamily="34" charset="-122"/>
+                <a:cs typeface="Arial" pitchFamily="34" charset="-120"/>
+              </a:rPr>
+              <a:t>• Speed to Floor: Deploy new product guidelines to 1000+ promoters in under an hour.</a:t>
+            </a:r>
+            <a:endParaRPr lang="en-US" sz="1200" dirty="0"/>
+          </a:p>
+          <a:p>
+            <a:pPr indent="0" marL="0">
+              <a:lnSpc>
+                <a:spcPts val="1800"/>
+              </a:lnSpc>
+              <a:buNone/>
+            </a:pPr>
+            <a:r>
+              <a:rPr lang="en-US" sz="1200" dirty="0">
+                <a:solidFill>
+                  <a:srgbClr val="334155"/>
+                </a:solidFill>
+                <a:latin typeface="Arial" pitchFamily="34" charset="0"/>
+                <a:ea typeface="Arial" pitchFamily="34" charset="-122"/>
+                <a:cs typeface="Arial" pitchFamily="34" charset="-120"/>
+              </a:rPr>
+              <a:t>• Compliance Auditing: Verify that promoter knowledge matches the target display guidelines.</a:t>
+            </a:r>
+            <a:endParaRPr lang="en-US" sz="1200" dirty="0"/>
+          </a:p>
+          <a:p>
+            <a:pPr indent="0" marL="0">
+              <a:lnSpc>
+                <a:spcPts val="1800"/>
+              </a:lnSpc>
+              <a:buNone/>
+            </a:pPr>
+            <a:r>
+              <a:rPr lang="en-US" sz="1200" dirty="0">
+                <a:solidFill>
+                  <a:srgbClr val="334155"/>
+                </a:solidFill>
+                <a:latin typeface="Arial" pitchFamily="34" charset="0"/>
+                <a:ea typeface="Arial" pitchFamily="34" charset="-122"/>
+                <a:cs typeface="Arial" pitchFamily="34" charset="-120"/>
+              </a:rPr>
+              <a:t>• ROI Metrics: Proven reduction in training costs by 45% compared to on-site trainer visits.</a:t>
             </a:r>
             <a:endParaRPr lang="en-US" sz="1200" dirty="0"/>
           </a:p>
@@ -14058,7 +14259,7 @@
                 <a:ea typeface="Arial" pitchFamily="34" charset="-122"/>
                 <a:cs typeface="Arial" pitchFamily="34" charset="-120"/>
               </a:rPr>
-              <a:t>Client Success Case Study: Unilever</a:t>
+              <a:t>Frontline Compliance Verification</a:t>
             </a:r>
             <a:endParaRPr lang="en-US" sz="2400" dirty="0"/>
           </a:p>
@@ -14172,76 +14373,76 @@
                 <a:ea typeface="Arial" pitchFamily="34" charset="-122"/>
                 <a:cs typeface="Arial" pitchFamily="34" charset="-120"/>
               </a:rPr>
-              <a:t>Real-world impact validated through corporate deployment (e.g. Unilever FMCG):</a:t>
-            </a:r>
-            <a:endParaRPr lang="en-US" sz="1200" dirty="0"/>
-          </a:p>
-          <a:p>
-            <a:pPr indent="0" marL="0">
-              <a:lnSpc>
-                <a:spcPts val="1800"/>
-              </a:lnSpc>
-              <a:buNone/>
-            </a:pPr>
-            <a:endParaRPr lang="en-US" sz="1200" dirty="0"/>
-          </a:p>
-          <a:p>
-            <a:pPr indent="0" marL="0">
-              <a:lnSpc>
-                <a:spcPts val="1800"/>
-              </a:lnSpc>
-              <a:buNone/>
-            </a:pPr>
-            <a:r>
-              <a:rPr lang="en-US" sz="1200" dirty="0">
-                <a:solidFill>
-                  <a:srgbClr val="334155"/>
-                </a:solidFill>
-                <a:latin typeface="Arial" pitchFamily="34" charset="0"/>
-                <a:ea typeface="Arial" pitchFamily="34" charset="-122"/>
-                <a:cs typeface="Arial" pitchFamily="34" charset="-120"/>
-              </a:rPr>
-              <a:t>• Challenge: Frontline promoters had poor comprehension of monthly promotional campaigns.</a:t>
-            </a:r>
-            <a:endParaRPr lang="en-US" sz="1200" dirty="0"/>
-          </a:p>
-          <a:p>
-            <a:pPr indent="0" marL="0">
-              <a:lnSpc>
-                <a:spcPts val="1800"/>
-              </a:lnSpc>
-              <a:buNone/>
-            </a:pPr>
-            <a:r>
-              <a:rPr lang="en-US" sz="1200" dirty="0">
-                <a:solidFill>
-                  <a:srgbClr val="334155"/>
-                </a:solidFill>
-                <a:latin typeface="Arial" pitchFamily="34" charset="0"/>
-                <a:ea typeface="Arial" pitchFamily="34" charset="-122"/>
-                <a:cs typeface="Arial" pitchFamily="34" charset="-120"/>
-              </a:rPr>
-              <a:t>• Solution: Deployed RetailEdge Pro for weekly live quizzes and training audits.</a:t>
-            </a:r>
-            <a:endParaRPr lang="en-US" sz="1200" dirty="0"/>
-          </a:p>
-          <a:p>
-            <a:pPr indent="0" marL="0">
-              <a:lnSpc>
-                <a:spcPts val="1800"/>
-              </a:lnSpc>
-              <a:buNone/>
-            </a:pPr>
-            <a:r>
-              <a:rPr lang="en-US" sz="1200" dirty="0">
-                <a:solidFill>
-                  <a:srgbClr val="334155"/>
-                </a:solidFill>
-                <a:latin typeface="Arial" pitchFamily="34" charset="0"/>
-                <a:ea typeface="Arial" pitchFamily="34" charset="-122"/>
-                <a:cs typeface="Arial" pitchFamily="34" charset="-120"/>
-              </a:rPr>
-              <a:t>• Results: CSAT rose to 4.85 / 5; frontline compliance reached 94.2%; sales increased by 18.4%.</a:t>
+              <a:t>Verify store execution guidelines and SOP adherence:</a:t>
+            </a:r>
+            <a:endParaRPr lang="en-US" sz="1200" dirty="0"/>
+          </a:p>
+          <a:p>
+            <a:pPr indent="0" marL="0">
+              <a:lnSpc>
+                <a:spcPts val="1800"/>
+              </a:lnSpc>
+              <a:buNone/>
+            </a:pPr>
+            <a:endParaRPr lang="en-US" sz="1200" dirty="0"/>
+          </a:p>
+          <a:p>
+            <a:pPr indent="0" marL="0">
+              <a:lnSpc>
+                <a:spcPts val="1800"/>
+              </a:lnSpc>
+              <a:buNone/>
+            </a:pPr>
+            <a:r>
+              <a:rPr lang="en-US" sz="1200" dirty="0">
+                <a:solidFill>
+                  <a:srgbClr val="334155"/>
+                </a:solidFill>
+                <a:latin typeface="Arial" pitchFamily="34" charset="0"/>
+                <a:ea typeface="Arial" pitchFamily="34" charset="-122"/>
+                <a:cs typeface="Arial" pitchFamily="34" charset="-120"/>
+              </a:rPr>
+              <a:t>• Audit Logs: Automated timestamps capture when a promoter completes standard training.</a:t>
+            </a:r>
+            <a:endParaRPr lang="en-US" sz="1200" dirty="0"/>
+          </a:p>
+          <a:p>
+            <a:pPr indent="0" marL="0">
+              <a:lnSpc>
+                <a:spcPts val="1800"/>
+              </a:lnSpc>
+              <a:buNone/>
+            </a:pPr>
+            <a:r>
+              <a:rPr lang="en-US" sz="1200" dirty="0">
+                <a:solidFill>
+                  <a:srgbClr val="334155"/>
+                </a:solidFill>
+                <a:latin typeface="Arial" pitchFamily="34" charset="0"/>
+                <a:ea typeface="Arial" pitchFamily="34" charset="-122"/>
+                <a:cs typeface="Arial" pitchFamily="34" charset="-120"/>
+              </a:rPr>
+              <a:t>• Error Flags: Instantly alerts supervisors when store accuracy falls below the 60% threshold.</a:t>
+            </a:r>
+            <a:endParaRPr lang="en-US" sz="1200" dirty="0"/>
+          </a:p>
+          <a:p>
+            <a:pPr indent="0" marL="0">
+              <a:lnSpc>
+                <a:spcPts val="1800"/>
+              </a:lnSpc>
+              <a:buNone/>
+            </a:pPr>
+            <a:r>
+              <a:rPr lang="en-US" sz="1200" dirty="0">
+                <a:solidFill>
+                  <a:srgbClr val="334155"/>
+                </a:solidFill>
+                <a:latin typeface="Arial" pitchFamily="34" charset="0"/>
+                <a:ea typeface="Arial" pitchFamily="34" charset="-122"/>
+                <a:cs typeface="Arial" pitchFamily="34" charset="-120"/>
+              </a:rPr>
+              <a:t>• Actionable Insights: Reports detail exact question options selected, identifying specific confusion points.</a:t>
             </a:r>
             <a:endParaRPr lang="en-US" sz="1200" dirty="0"/>
           </a:p>
@@ -14312,7 +14513,7 @@
                 <a:ea typeface="Arial" pitchFamily="34" charset="-122"/>
                 <a:cs typeface="Arial" pitchFamily="34" charset="-120"/>
               </a:rPr>
-              <a:t>DEPLOYMENT ROADMAP</a:t>
+              <a:t>BUSINESS VALUE &amp; ROI</a:t>
             </a:r>
             <a:endParaRPr lang="en-US" sz="1000" dirty="0"/>
           </a:p>
@@ -14351,7 +14552,7 @@
                 <a:ea typeface="Arial" pitchFamily="34" charset="-122"/>
                 <a:cs typeface="Arial" pitchFamily="34" charset="-120"/>
               </a:rPr>
-              <a:t>LMS Deployment &amp; Launch Phases</a:t>
+              <a:t>Client Success Case Study: Unilever</a:t>
             </a:r>
             <a:endParaRPr lang="en-US" sz="2400" dirty="0"/>
           </a:p>
@@ -14465,96 +14666,76 @@
                 <a:ea typeface="Arial" pitchFamily="34" charset="-122"/>
                 <a:cs typeface="Arial" pitchFamily="34" charset="-120"/>
               </a:rPr>
-              <a:t>Structured plan to deploy the platform across retail zones:</a:t>
-            </a:r>
-            <a:endParaRPr lang="en-US" sz="1200" dirty="0"/>
-          </a:p>
-          <a:p>
-            <a:pPr indent="0" marL="0">
-              <a:lnSpc>
-                <a:spcPts val="1800"/>
-              </a:lnSpc>
-              <a:buNone/>
-            </a:pPr>
-            <a:endParaRPr lang="en-US" sz="1200" dirty="0"/>
-          </a:p>
-          <a:p>
-            <a:pPr indent="0" marL="0">
-              <a:lnSpc>
-                <a:spcPts val="1800"/>
-              </a:lnSpc>
-              <a:buNone/>
-            </a:pPr>
-            <a:r>
-              <a:rPr lang="en-US" sz="1200" dirty="0">
-                <a:solidFill>
-                  <a:srgbClr val="334155"/>
-                </a:solidFill>
-                <a:latin typeface="Arial" pitchFamily="34" charset="0"/>
-                <a:ea typeface="Arial" pitchFamily="34" charset="-122"/>
-                <a:cs typeface="Arial" pitchFamily="34" charset="-120"/>
-              </a:rPr>
-              <a:t>• Phase 1: Database Setup and Administrator Seeding (Completed).</a:t>
-            </a:r>
-            <a:endParaRPr lang="en-US" sz="1200" dirty="0"/>
-          </a:p>
-          <a:p>
-            <a:pPr indent="0" marL="0">
-              <a:lnSpc>
-                <a:spcPts val="1800"/>
-              </a:lnSpc>
-              <a:buNone/>
-            </a:pPr>
-            <a:r>
-              <a:rPr lang="en-US" sz="1200" dirty="0">
-                <a:solidFill>
-                  <a:srgbClr val="334155"/>
-                </a:solidFill>
-                <a:latin typeface="Arial" pitchFamily="34" charset="0"/>
-                <a:ea typeface="Arial" pitchFamily="34" charset="-122"/>
-                <a:cs typeface="Arial" pitchFamily="34" charset="-120"/>
-              </a:rPr>
-              <a:t>• Phase 2: Pilot Rollout to Selected Store Hubs (Week 1-2).</a:t>
-            </a:r>
-            <a:endParaRPr lang="en-US" sz="1200" dirty="0"/>
-          </a:p>
-          <a:p>
-            <a:pPr indent="0" marL="0">
-              <a:lnSpc>
-                <a:spcPts val="1800"/>
-              </a:lnSpc>
-              <a:buNone/>
-            </a:pPr>
-            <a:r>
-              <a:rPr lang="en-US" sz="1200" dirty="0">
-                <a:solidFill>
-                  <a:srgbClr val="334155"/>
-                </a:solidFill>
-                <a:latin typeface="Arial" pitchFamily="34" charset="0"/>
-                <a:ea typeface="Arial" pitchFamily="34" charset="-122"/>
-                <a:cs typeface="Arial" pitchFamily="34" charset="-120"/>
-              </a:rPr>
-              <a:t>• Phase 3: Regional Training for Trainers and Supervisors (Week 3).</a:t>
-            </a:r>
-            <a:endParaRPr lang="en-US" sz="1200" dirty="0"/>
-          </a:p>
-          <a:p>
-            <a:pPr indent="0" marL="0">
-              <a:lnSpc>
-                <a:spcPts val="1800"/>
-              </a:lnSpc>
-              <a:buNone/>
-            </a:pPr>
-            <a:r>
-              <a:rPr lang="en-US" sz="1200" dirty="0">
-                <a:solidFill>
-                  <a:srgbClr val="334155"/>
-                </a:solidFill>
-                <a:latin typeface="Arial" pitchFamily="34" charset="0"/>
-                <a:ea typeface="Arial" pitchFamily="34" charset="-122"/>
-                <a:cs typeface="Arial" pitchFamily="34" charset="-120"/>
-              </a:rPr>
-              <a:t>• Phase 4: Full Promoter Network Launch and Live Arena Activation (Week 4).</a:t>
+              <a:t>Real-world impact validated through corporate deployment (e.g. Unilever FMCG):</a:t>
+            </a:r>
+            <a:endParaRPr lang="en-US" sz="1200" dirty="0"/>
+          </a:p>
+          <a:p>
+            <a:pPr indent="0" marL="0">
+              <a:lnSpc>
+                <a:spcPts val="1800"/>
+              </a:lnSpc>
+              <a:buNone/>
+            </a:pPr>
+            <a:endParaRPr lang="en-US" sz="1200" dirty="0"/>
+          </a:p>
+          <a:p>
+            <a:pPr indent="0" marL="0">
+              <a:lnSpc>
+                <a:spcPts val="1800"/>
+              </a:lnSpc>
+              <a:buNone/>
+            </a:pPr>
+            <a:r>
+              <a:rPr lang="en-US" sz="1200" dirty="0">
+                <a:solidFill>
+                  <a:srgbClr val="334155"/>
+                </a:solidFill>
+                <a:latin typeface="Arial" pitchFamily="34" charset="0"/>
+                <a:ea typeface="Arial" pitchFamily="34" charset="-122"/>
+                <a:cs typeface="Arial" pitchFamily="34" charset="-120"/>
+              </a:rPr>
+              <a:t>• Challenge: Frontline promoters had poor comprehension of monthly promotional campaigns.</a:t>
+            </a:r>
+            <a:endParaRPr lang="en-US" sz="1200" dirty="0"/>
+          </a:p>
+          <a:p>
+            <a:pPr indent="0" marL="0">
+              <a:lnSpc>
+                <a:spcPts val="1800"/>
+              </a:lnSpc>
+              <a:buNone/>
+            </a:pPr>
+            <a:r>
+              <a:rPr lang="en-US" sz="1200" dirty="0">
+                <a:solidFill>
+                  <a:srgbClr val="334155"/>
+                </a:solidFill>
+                <a:latin typeface="Arial" pitchFamily="34" charset="0"/>
+                <a:ea typeface="Arial" pitchFamily="34" charset="-122"/>
+                <a:cs typeface="Arial" pitchFamily="34" charset="-120"/>
+              </a:rPr>
+              <a:t>• Solution: Deployed RetailEdge Pro for weekly live quizzes and training audits.</a:t>
+            </a:r>
+            <a:endParaRPr lang="en-US" sz="1200" dirty="0"/>
+          </a:p>
+          <a:p>
+            <a:pPr indent="0" marL="0">
+              <a:lnSpc>
+                <a:spcPts val="1800"/>
+              </a:lnSpc>
+              <a:buNone/>
+            </a:pPr>
+            <a:r>
+              <a:rPr lang="en-US" sz="1200" dirty="0">
+                <a:solidFill>
+                  <a:srgbClr val="334155"/>
+                </a:solidFill>
+                <a:latin typeface="Arial" pitchFamily="34" charset="0"/>
+                <a:ea typeface="Arial" pitchFamily="34" charset="-122"/>
+                <a:cs typeface="Arial" pitchFamily="34" charset="-120"/>
+              </a:rPr>
+              <a:t>• Results: CSAT rose to 4.85 / 5; frontline compliance reached 94.2%; sales increased by 18.4%.</a:t>
             </a:r>
             <a:endParaRPr lang="en-US" sz="1200" dirty="0"/>
           </a:p>
@@ -14664,7 +14845,7 @@
                 <a:ea typeface="Arial" pitchFamily="34" charset="-122"/>
                 <a:cs typeface="Arial" pitchFamily="34" charset="-120"/>
               </a:rPr>
-              <a:t>Technical Integration Roadmap</a:t>
+              <a:t>LMS Deployment &amp; Launch Phases</a:t>
             </a:r>
             <a:endParaRPr lang="en-US" sz="2400" dirty="0"/>
           </a:p>
@@ -14778,76 +14959,96 @@
                 <a:ea typeface="Arial" pitchFamily="34" charset="-122"/>
                 <a:cs typeface="Arial" pitchFamily="34" charset="-120"/>
               </a:rPr>
-              <a:t>Simple integration path with existing corporate directories and tools:</a:t>
-            </a:r>
-            <a:endParaRPr lang="en-US" sz="1200" dirty="0"/>
-          </a:p>
-          <a:p>
-            <a:pPr indent="0" marL="0">
-              <a:lnSpc>
-                <a:spcPts val="1800"/>
-              </a:lnSpc>
-              <a:buNone/>
-            </a:pPr>
-            <a:endParaRPr lang="en-US" sz="1200" dirty="0"/>
-          </a:p>
-          <a:p>
-            <a:pPr indent="0" marL="0">
-              <a:lnSpc>
-                <a:spcPts val="1800"/>
-              </a:lnSpc>
-              <a:buNone/>
-            </a:pPr>
-            <a:r>
-              <a:rPr lang="en-US" sz="1200" dirty="0">
-                <a:solidFill>
-                  <a:srgbClr val="334155"/>
-                </a:solidFill>
-                <a:latin typeface="Arial" pitchFamily="34" charset="0"/>
-                <a:ea typeface="Arial" pitchFamily="34" charset="-122"/>
-                <a:cs typeface="Arial" pitchFamily="34" charset="-120"/>
-              </a:rPr>
-              <a:t>• Single Sign-On (SSO): Integrates with Active Directory and Okta (Future phase).</a:t>
-            </a:r>
-            <a:endParaRPr lang="en-US" sz="1200" dirty="0"/>
-          </a:p>
-          <a:p>
-            <a:pPr indent="0" marL="0">
-              <a:lnSpc>
-                <a:spcPts val="1800"/>
-              </a:lnSpc>
-              <a:buNone/>
-            </a:pPr>
-            <a:r>
-              <a:rPr lang="en-US" sz="1200" dirty="0">
-                <a:solidFill>
-                  <a:srgbClr val="334155"/>
-                </a:solidFill>
-                <a:latin typeface="Arial" pitchFamily="34" charset="0"/>
-                <a:ea typeface="Arial" pitchFamily="34" charset="-122"/>
-                <a:cs typeface="Arial" pitchFamily="34" charset="-120"/>
-              </a:rPr>
-              <a:t>• Video Tools: Out-of-the-box Jitsi Meet integration for remote training sessions.</a:t>
-            </a:r>
-            <a:endParaRPr lang="en-US" sz="1200" dirty="0"/>
-          </a:p>
-          <a:p>
-            <a:pPr indent="0" marL="0">
-              <a:lnSpc>
-                <a:spcPts val="1800"/>
-              </a:lnSpc>
-              <a:buNone/>
-            </a:pPr>
-            <a:r>
-              <a:rPr lang="en-US" sz="1200" dirty="0">
-                <a:solidFill>
-                  <a:srgbClr val="334155"/>
-                </a:solidFill>
-                <a:latin typeface="Arial" pitchFamily="34" charset="0"/>
-                <a:ea typeface="Arial" pitchFamily="34" charset="-122"/>
-                <a:cs typeface="Arial" pitchFamily="34" charset="-120"/>
-              </a:rPr>
-              <a:t>• API Services: RESTful endpoints export attendance logs to SAP or Oracle HR MS.</a:t>
+              <a:t>Structured plan to deploy the platform across retail zones:</a:t>
+            </a:r>
+            <a:endParaRPr lang="en-US" sz="1200" dirty="0"/>
+          </a:p>
+          <a:p>
+            <a:pPr indent="0" marL="0">
+              <a:lnSpc>
+                <a:spcPts val="1800"/>
+              </a:lnSpc>
+              <a:buNone/>
+            </a:pPr>
+            <a:endParaRPr lang="en-US" sz="1200" dirty="0"/>
+          </a:p>
+          <a:p>
+            <a:pPr indent="0" marL="0">
+              <a:lnSpc>
+                <a:spcPts val="1800"/>
+              </a:lnSpc>
+              <a:buNone/>
+            </a:pPr>
+            <a:r>
+              <a:rPr lang="en-US" sz="1200" dirty="0">
+                <a:solidFill>
+                  <a:srgbClr val="334155"/>
+                </a:solidFill>
+                <a:latin typeface="Arial" pitchFamily="34" charset="0"/>
+                <a:ea typeface="Arial" pitchFamily="34" charset="-122"/>
+                <a:cs typeface="Arial" pitchFamily="34" charset="-120"/>
+              </a:rPr>
+              <a:t>• Phase 1: Database Setup and Administrator Seeding (Completed).</a:t>
+            </a:r>
+            <a:endParaRPr lang="en-US" sz="1200" dirty="0"/>
+          </a:p>
+          <a:p>
+            <a:pPr indent="0" marL="0">
+              <a:lnSpc>
+                <a:spcPts val="1800"/>
+              </a:lnSpc>
+              <a:buNone/>
+            </a:pPr>
+            <a:r>
+              <a:rPr lang="en-US" sz="1200" dirty="0">
+                <a:solidFill>
+                  <a:srgbClr val="334155"/>
+                </a:solidFill>
+                <a:latin typeface="Arial" pitchFamily="34" charset="0"/>
+                <a:ea typeface="Arial" pitchFamily="34" charset="-122"/>
+                <a:cs typeface="Arial" pitchFamily="34" charset="-120"/>
+              </a:rPr>
+              <a:t>• Phase 2: Pilot Rollout to Selected Store Hubs (Week 1-2).</a:t>
+            </a:r>
+            <a:endParaRPr lang="en-US" sz="1200" dirty="0"/>
+          </a:p>
+          <a:p>
+            <a:pPr indent="0" marL="0">
+              <a:lnSpc>
+                <a:spcPts val="1800"/>
+              </a:lnSpc>
+              <a:buNone/>
+            </a:pPr>
+            <a:r>
+              <a:rPr lang="en-US" sz="1200" dirty="0">
+                <a:solidFill>
+                  <a:srgbClr val="334155"/>
+                </a:solidFill>
+                <a:latin typeface="Arial" pitchFamily="34" charset="0"/>
+                <a:ea typeface="Arial" pitchFamily="34" charset="-122"/>
+                <a:cs typeface="Arial" pitchFamily="34" charset="-120"/>
+              </a:rPr>
+              <a:t>• Phase 3: Regional Training for Trainers and Supervisors (Week 3).</a:t>
+            </a:r>
+            <a:endParaRPr lang="en-US" sz="1200" dirty="0"/>
+          </a:p>
+          <a:p>
+            <a:pPr indent="0" marL="0">
+              <a:lnSpc>
+                <a:spcPts val="1800"/>
+              </a:lnSpc>
+              <a:buNone/>
+            </a:pPr>
+            <a:r>
+              <a:rPr lang="en-US" sz="1200" dirty="0">
+                <a:solidFill>
+                  <a:srgbClr val="334155"/>
+                </a:solidFill>
+                <a:latin typeface="Arial" pitchFamily="34" charset="0"/>
+                <a:ea typeface="Arial" pitchFamily="34" charset="-122"/>
+                <a:cs typeface="Arial" pitchFamily="34" charset="-120"/>
+              </a:rPr>
+              <a:t>• Phase 4: Full Promoter Network Launch and Live Arena Activation (Week 4).</a:t>
             </a:r>
             <a:endParaRPr lang="en-US" sz="1200" dirty="0"/>
           </a:p>
@@ -14918,7 +15119,7 @@
                 <a:ea typeface="Arial" pitchFamily="34" charset="-122"/>
                 <a:cs typeface="Arial" pitchFamily="34" charset="-120"/>
               </a:rPr>
-              <a:t>TECHNICAL SPECIFICATIONS</a:t>
+              <a:t>DEPLOYMENT ROADMAP</a:t>
             </a:r>
             <a:endParaRPr lang="en-US" sz="1000" dirty="0"/>
           </a:p>
@@ -14957,7 +15158,7 @@
                 <a:ea typeface="Arial" pitchFamily="34" charset="-122"/>
                 <a:cs typeface="Arial" pitchFamily="34" charset="-120"/>
               </a:rPr>
-              <a:t>Security &amp; Data Integrity</a:t>
+              <a:t>Technical Integration Roadmap</a:t>
             </a:r>
             <a:endParaRPr lang="en-US" sz="2400" dirty="0"/>
           </a:p>
@@ -15071,96 +15272,76 @@
                 <a:ea typeface="Arial" pitchFamily="34" charset="-122"/>
                 <a:cs typeface="Arial" pitchFamily="34" charset="-120"/>
               </a:rPr>
-              <a:t>Enterprise-grade security controls protect sensitive company data:</a:t>
-            </a:r>
-            <a:endParaRPr lang="en-US" sz="1200" dirty="0"/>
-          </a:p>
-          <a:p>
-            <a:pPr indent="0" marL="0">
-              <a:lnSpc>
-                <a:spcPts val="1800"/>
-              </a:lnSpc>
-              <a:buNone/>
-            </a:pPr>
-            <a:endParaRPr lang="en-US" sz="1200" dirty="0"/>
-          </a:p>
-          <a:p>
-            <a:pPr indent="0" marL="0">
-              <a:lnSpc>
-                <a:spcPts val="1800"/>
-              </a:lnSpc>
-              <a:buNone/>
-            </a:pPr>
-            <a:r>
-              <a:rPr lang="en-US" sz="1200" dirty="0">
-                <a:solidFill>
-                  <a:srgbClr val="334155"/>
-                </a:solidFill>
-                <a:latin typeface="Arial" pitchFamily="34" charset="0"/>
-                <a:ea typeface="Arial" pitchFamily="34" charset="-122"/>
-                <a:cs typeface="Arial" pitchFamily="34" charset="-120"/>
-              </a:rPr>
-              <a:t>• Secure Storage: SQLite backend with Sequelize ORM validation layers.</a:t>
-            </a:r>
-            <a:endParaRPr lang="en-US" sz="1200" dirty="0"/>
-          </a:p>
-          <a:p>
-            <a:pPr indent="0" marL="0">
-              <a:lnSpc>
-                <a:spcPts val="1800"/>
-              </a:lnSpc>
-              <a:buNone/>
-            </a:pPr>
-            <a:r>
-              <a:rPr lang="en-US" sz="1200" dirty="0">
-                <a:solidFill>
-                  <a:srgbClr val="334155"/>
-                </a:solidFill>
-                <a:latin typeface="Arial" pitchFamily="34" charset="0"/>
-                <a:ea typeface="Arial" pitchFamily="34" charset="-122"/>
-                <a:cs typeface="Arial" pitchFamily="34" charset="-120"/>
-              </a:rPr>
-              <a:t>• Password Protection: All passwords hashed using industry-standard bcrypt.</a:t>
-            </a:r>
-            <a:endParaRPr lang="en-US" sz="1200" dirty="0"/>
-          </a:p>
-          <a:p>
-            <a:pPr indent="0" marL="0">
-              <a:lnSpc>
-                <a:spcPts val="1800"/>
-              </a:lnSpc>
-              <a:buNone/>
-            </a:pPr>
-            <a:r>
-              <a:rPr lang="en-US" sz="1200" dirty="0">
-                <a:solidFill>
-                  <a:srgbClr val="334155"/>
-                </a:solidFill>
-                <a:latin typeface="Arial" pitchFamily="34" charset="0"/>
-                <a:ea typeface="Arial" pitchFamily="34" charset="-122"/>
-                <a:cs typeface="Arial" pitchFamily="34" charset="-120"/>
-              </a:rPr>
-              <a:t>• Secure Sessions: Stateless JWT authentication tokens with auto-expire controls.</a:t>
-            </a:r>
-            <a:endParaRPr lang="en-US" sz="1200" dirty="0"/>
-          </a:p>
-          <a:p>
-            <a:pPr indent="0" marL="0">
-              <a:lnSpc>
-                <a:spcPts val="1800"/>
-              </a:lnSpc>
-              <a:buNone/>
-            </a:pPr>
-            <a:r>
-              <a:rPr lang="en-US" sz="1200" dirty="0">
-                <a:solidFill>
-                  <a:srgbClr val="334155"/>
-                </a:solidFill>
-                <a:latin typeface="Arial" pitchFamily="34" charset="0"/>
-                <a:ea typeface="Arial" pitchFamily="34" charset="-122"/>
-                <a:cs typeface="Arial" pitchFamily="34" charset="-120"/>
-              </a:rPr>
-              <a:t>• Access Auditing: Only authorized roles can download XLS and PPTX summaries.</a:t>
+              <a:t>Simple integration path with existing corporate directories and tools:</a:t>
+            </a:r>
+            <a:endParaRPr lang="en-US" sz="1200" dirty="0"/>
+          </a:p>
+          <a:p>
+            <a:pPr indent="0" marL="0">
+              <a:lnSpc>
+                <a:spcPts val="1800"/>
+              </a:lnSpc>
+              <a:buNone/>
+            </a:pPr>
+            <a:endParaRPr lang="en-US" sz="1200" dirty="0"/>
+          </a:p>
+          <a:p>
+            <a:pPr indent="0" marL="0">
+              <a:lnSpc>
+                <a:spcPts val="1800"/>
+              </a:lnSpc>
+              <a:buNone/>
+            </a:pPr>
+            <a:r>
+              <a:rPr lang="en-US" sz="1200" dirty="0">
+                <a:solidFill>
+                  <a:srgbClr val="334155"/>
+                </a:solidFill>
+                <a:latin typeface="Arial" pitchFamily="34" charset="0"/>
+                <a:ea typeface="Arial" pitchFamily="34" charset="-122"/>
+                <a:cs typeface="Arial" pitchFamily="34" charset="-120"/>
+              </a:rPr>
+              <a:t>• Single Sign-On (SSO): Integrates with Active Directory and Okta (Future phase).</a:t>
+            </a:r>
+            <a:endParaRPr lang="en-US" sz="1200" dirty="0"/>
+          </a:p>
+          <a:p>
+            <a:pPr indent="0" marL="0">
+              <a:lnSpc>
+                <a:spcPts val="1800"/>
+              </a:lnSpc>
+              <a:buNone/>
+            </a:pPr>
+            <a:r>
+              <a:rPr lang="en-US" sz="1200" dirty="0">
+                <a:solidFill>
+                  <a:srgbClr val="334155"/>
+                </a:solidFill>
+                <a:latin typeface="Arial" pitchFamily="34" charset="0"/>
+                <a:ea typeface="Arial" pitchFamily="34" charset="-122"/>
+                <a:cs typeface="Arial" pitchFamily="34" charset="-120"/>
+              </a:rPr>
+              <a:t>• Video Tools: Out-of-the-box Jitsi Meet integration for remote training sessions.</a:t>
+            </a:r>
+            <a:endParaRPr lang="en-US" sz="1200" dirty="0"/>
+          </a:p>
+          <a:p>
+            <a:pPr indent="0" marL="0">
+              <a:lnSpc>
+                <a:spcPts val="1800"/>
+              </a:lnSpc>
+              <a:buNone/>
+            </a:pPr>
+            <a:r>
+              <a:rPr lang="en-US" sz="1200" dirty="0">
+                <a:solidFill>
+                  <a:srgbClr val="334155"/>
+                </a:solidFill>
+                <a:latin typeface="Arial" pitchFamily="34" charset="0"/>
+                <a:ea typeface="Arial" pitchFamily="34" charset="-122"/>
+                <a:cs typeface="Arial" pitchFamily="34" charset="-120"/>
+              </a:rPr>
+              <a:t>• API Services: RESTful endpoints export attendance logs to SAP or Oracle HR MS.</a:t>
             </a:r>
             <a:endParaRPr lang="en-US" sz="1200" dirty="0"/>
           </a:p>
@@ -15270,7 +15451,7 @@
                 <a:ea typeface="Arial" pitchFamily="34" charset="-122"/>
                 <a:cs typeface="Arial" pitchFamily="34" charset="-120"/>
               </a:rPr>
-              <a:t>Platform Scalability &amp; Future Outlook</a:t>
+              <a:t>Security &amp; Data Integrity</a:t>
             </a:r>
             <a:endParaRPr lang="en-US" sz="2400" dirty="0"/>
           </a:p>
@@ -15384,76 +15565,96 @@
                 <a:ea typeface="Arial" pitchFamily="34" charset="-122"/>
                 <a:cs typeface="Arial" pitchFamily="34" charset="-120"/>
               </a:rPr>
-              <a:t>Designed to scale with growing promoter networks and store locations:</a:t>
-            </a:r>
-            <a:endParaRPr lang="en-US" sz="1200" dirty="0"/>
-          </a:p>
-          <a:p>
-            <a:pPr indent="0" marL="0">
-              <a:lnSpc>
-                <a:spcPts val="1800"/>
-              </a:lnSpc>
-              <a:buNone/>
-            </a:pPr>
-            <a:endParaRPr lang="en-US" sz="1200" dirty="0"/>
-          </a:p>
-          <a:p>
-            <a:pPr indent="0" marL="0">
-              <a:lnSpc>
-                <a:spcPts val="1800"/>
-              </a:lnSpc>
-              <a:buNone/>
-            </a:pPr>
-            <a:r>
-              <a:rPr lang="en-US" sz="1200" dirty="0">
-                <a:solidFill>
-                  <a:srgbClr val="334155"/>
-                </a:solidFill>
-                <a:latin typeface="Arial" pitchFamily="34" charset="0"/>
-                <a:ea typeface="Arial" pitchFamily="34" charset="-122"/>
-                <a:cs typeface="Arial" pitchFamily="34" charset="-120"/>
-              </a:rPr>
-              <a:t>• Infrastructure: Light node backend handles thousands of concurrent socket events.</a:t>
-            </a:r>
-            <a:endParaRPr lang="en-US" sz="1200" dirty="0"/>
-          </a:p>
-          <a:p>
-            <a:pPr indent="0" marL="0">
-              <a:lnSpc>
-                <a:spcPts val="1800"/>
-              </a:lnSpc>
-              <a:buNone/>
-            </a:pPr>
-            <a:r>
-              <a:rPr lang="en-US" sz="1200" dirty="0">
-                <a:solidFill>
-                  <a:srgbClr val="334155"/>
-                </a:solidFill>
-                <a:latin typeface="Arial" pitchFamily="34" charset="0"/>
-                <a:ea typeface="Arial" pitchFamily="34" charset="-122"/>
-                <a:cs typeface="Arial" pitchFamily="34" charset="-120"/>
-              </a:rPr>
-              <a:t>• Native Apps: Upcoming iOS and Android wrapper launch to support native notifications.</a:t>
-            </a:r>
-            <a:endParaRPr lang="en-US" sz="1200" dirty="0"/>
-          </a:p>
-          <a:p>
-            <a:pPr indent="0" marL="0">
-              <a:lnSpc>
-                <a:spcPts val="1800"/>
-              </a:lnSpc>
-              <a:buNone/>
-            </a:pPr>
-            <a:r>
-              <a:rPr lang="en-US" sz="1200" dirty="0">
-                <a:solidFill>
-                  <a:srgbClr val="334155"/>
-                </a:solidFill>
-                <a:latin typeface="Arial" pitchFamily="34" charset="0"/>
-                <a:ea typeface="Arial" pitchFamily="34" charset="-122"/>
-                <a:cs typeface="Arial" pitchFamily="34" charset="-120"/>
-              </a:rPr>
-              <a:t>• AI Analytics: Future predictive reports to identify high-turnover stores ahead of time.</a:t>
+              <a:t>Enterprise-grade security controls protect sensitive company data:</a:t>
+            </a:r>
+            <a:endParaRPr lang="en-US" sz="1200" dirty="0"/>
+          </a:p>
+          <a:p>
+            <a:pPr indent="0" marL="0">
+              <a:lnSpc>
+                <a:spcPts val="1800"/>
+              </a:lnSpc>
+              <a:buNone/>
+            </a:pPr>
+            <a:endParaRPr lang="en-US" sz="1200" dirty="0"/>
+          </a:p>
+          <a:p>
+            <a:pPr indent="0" marL="0">
+              <a:lnSpc>
+                <a:spcPts val="1800"/>
+              </a:lnSpc>
+              <a:buNone/>
+            </a:pPr>
+            <a:r>
+              <a:rPr lang="en-US" sz="1200" dirty="0">
+                <a:solidFill>
+                  <a:srgbClr val="334155"/>
+                </a:solidFill>
+                <a:latin typeface="Arial" pitchFamily="34" charset="0"/>
+                <a:ea typeface="Arial" pitchFamily="34" charset="-122"/>
+                <a:cs typeface="Arial" pitchFamily="34" charset="-120"/>
+              </a:rPr>
+              <a:t>• Secure Storage: PostgreSQL backend with Sequelize ORM validation layers.</a:t>
+            </a:r>
+            <a:endParaRPr lang="en-US" sz="1200" dirty="0"/>
+          </a:p>
+          <a:p>
+            <a:pPr indent="0" marL="0">
+              <a:lnSpc>
+                <a:spcPts val="1800"/>
+              </a:lnSpc>
+              <a:buNone/>
+            </a:pPr>
+            <a:r>
+              <a:rPr lang="en-US" sz="1200" dirty="0">
+                <a:solidFill>
+                  <a:srgbClr val="334155"/>
+                </a:solidFill>
+                <a:latin typeface="Arial" pitchFamily="34" charset="0"/>
+                <a:ea typeface="Arial" pitchFamily="34" charset="-122"/>
+                <a:cs typeface="Arial" pitchFamily="34" charset="-120"/>
+              </a:rPr>
+              <a:t>• Password Protection: All passwords hashed using industry-standard bcrypt.</a:t>
+            </a:r>
+            <a:endParaRPr lang="en-US" sz="1200" dirty="0"/>
+          </a:p>
+          <a:p>
+            <a:pPr indent="0" marL="0">
+              <a:lnSpc>
+                <a:spcPts val="1800"/>
+              </a:lnSpc>
+              <a:buNone/>
+            </a:pPr>
+            <a:r>
+              <a:rPr lang="en-US" sz="1200" dirty="0">
+                <a:solidFill>
+                  <a:srgbClr val="334155"/>
+                </a:solidFill>
+                <a:latin typeface="Arial" pitchFamily="34" charset="0"/>
+                <a:ea typeface="Arial" pitchFamily="34" charset="-122"/>
+                <a:cs typeface="Arial" pitchFamily="34" charset="-120"/>
+              </a:rPr>
+              <a:t>• Secure Sessions: Stateless JWT authentication tokens with auto-expire controls.</a:t>
+            </a:r>
+            <a:endParaRPr lang="en-US" sz="1200" dirty="0"/>
+          </a:p>
+          <a:p>
+            <a:pPr indent="0" marL="0">
+              <a:lnSpc>
+                <a:spcPts val="1800"/>
+              </a:lnSpc>
+              <a:buNone/>
+            </a:pPr>
+            <a:r>
+              <a:rPr lang="en-US" sz="1200" dirty="0">
+                <a:solidFill>
+                  <a:srgbClr val="334155"/>
+                </a:solidFill>
+                <a:latin typeface="Arial" pitchFamily="34" charset="0"/>
+                <a:ea typeface="Arial" pitchFamily="34" charset="-122"/>
+                <a:cs typeface="Arial" pitchFamily="34" charset="-120"/>
+              </a:rPr>
+              <a:t>• Access Auditing: Only authorized roles can download XLS and PPTX summaries.</a:t>
             </a:r>
             <a:endParaRPr lang="en-US" sz="1200" dirty="0"/>
           </a:p>
@@ -15786,6 +15987,299 @@
     <p:bg>
       <p:bgPr>
         <a:solidFill>
+          <a:srgbClr val="F8FAFC"/>
+        </a:solidFill>
+      </p:bgPr>
+    </p:bg>
+    <p:spTree>
+      <p:nvGrpSpPr>
+        <p:cNvPr id="1" name=""/>
+        <p:cNvGrpSpPr/>
+        <p:nvPr/>
+      </p:nvGrpSpPr>
+      <p:grpSpPr>
+        <a:xfrm>
+          <a:off x="0" y="0"/>
+          <a:ext cx="0" cy="0"/>
+          <a:chOff x="0" y="0"/>
+          <a:chExt cx="0" cy="0"/>
+        </a:xfrm>
+      </p:grpSpPr>
+      <p:sp>
+        <p:nvSpPr>
+          <p:cNvPr id="2" name="Text 0"/>
+          <p:cNvSpPr/>
+          <p:nvPr/>
+        </p:nvSpPr>
+        <p:spPr>
+          <a:xfrm>
+            <a:off x="548640" y="365760"/>
+            <a:ext cx="9144000" cy="274320"/>
+          </a:xfrm>
+          <a:prstGeom prst="rect">
+            <a:avLst/>
+          </a:prstGeom>
+          <a:noFill/>
+          <a:ln/>
+        </p:spPr>
+        <p:txBody>
+          <a:bodyPr wrap="square" rtlCol="0" anchor="ctr"/>
+          <a:lstStyle/>
+          <a:p>
+            <a:pPr indent="0" marL="0">
+              <a:buNone/>
+            </a:pPr>
+            <a:r>
+              <a:rPr lang="en-US" sz="1000" b="1" dirty="0">
+                <a:solidFill>
+                  <a:srgbClr val="2563EB"/>
+                </a:solidFill>
+                <a:latin typeface="Arial" pitchFamily="34" charset="0"/>
+                <a:ea typeface="Arial" pitchFamily="34" charset="-122"/>
+                <a:cs typeface="Arial" pitchFamily="34" charset="-120"/>
+              </a:rPr>
+              <a:t>TECHNICAL SPECIFICATIONS</a:t>
+            </a:r>
+            <a:endParaRPr lang="en-US" sz="1000" dirty="0"/>
+          </a:p>
+        </p:txBody>
+      </p:sp>
+      <p:sp>
+        <p:nvSpPr>
+          <p:cNvPr id="3" name="Text 1"/>
+          <p:cNvSpPr/>
+          <p:nvPr/>
+        </p:nvSpPr>
+        <p:spPr>
+          <a:xfrm>
+            <a:off x="548640" y="640080"/>
+            <a:ext cx="9144000" cy="548640"/>
+          </a:xfrm>
+          <a:prstGeom prst="rect">
+            <a:avLst/>
+          </a:prstGeom>
+          <a:noFill/>
+          <a:ln/>
+        </p:spPr>
+        <p:txBody>
+          <a:bodyPr wrap="square" rtlCol="0" anchor="ctr"/>
+          <a:lstStyle/>
+          <a:p>
+            <a:pPr indent="0" marL="0">
+              <a:buNone/>
+            </a:pPr>
+            <a:r>
+              <a:rPr lang="en-US" sz="2400" b="1" dirty="0">
+                <a:solidFill>
+                  <a:srgbClr val="0F172A"/>
+                </a:solidFill>
+                <a:latin typeface="Arial" pitchFamily="34" charset="0"/>
+                <a:ea typeface="Arial" pitchFamily="34" charset="-122"/>
+                <a:cs typeface="Arial" pitchFamily="34" charset="-120"/>
+              </a:rPr>
+              <a:t>Platform Scalability &amp; Future Outlook</a:t>
+            </a:r>
+            <a:endParaRPr lang="en-US" sz="2400" dirty="0"/>
+          </a:p>
+        </p:txBody>
+      </p:sp>
+      <p:sp>
+        <p:nvSpPr>
+          <p:cNvPr id="4" name="Text 2"/>
+          <p:cNvSpPr/>
+          <p:nvPr/>
+        </p:nvSpPr>
+        <p:spPr>
+          <a:xfrm>
+            <a:off x="548640" y="6400800"/>
+            <a:ext cx="5486400" cy="274320"/>
+          </a:xfrm>
+          <a:prstGeom prst="rect">
+            <a:avLst/>
+          </a:prstGeom>
+          <a:noFill/>
+          <a:ln/>
+        </p:spPr>
+        <p:txBody>
+          <a:bodyPr wrap="square" rtlCol="0" anchor="ctr"/>
+          <a:lstStyle/>
+          <a:p>
+            <a:pPr indent="0" marL="0">
+              <a:buNone/>
+            </a:pPr>
+            <a:r>
+              <a:rPr lang="en-US" sz="900" dirty="0">
+                <a:solidFill>
+                  <a:srgbClr val="475569"/>
+                </a:solidFill>
+              </a:rPr>
+              <a:t>RetailEdge Pro — Executive Presentation</a:t>
+            </a:r>
+            <a:endParaRPr lang="en-US" sz="900" dirty="0"/>
+          </a:p>
+        </p:txBody>
+      </p:sp>
+      <p:sp>
+        <p:nvSpPr>
+          <p:cNvPr id="5" name="Text 3"/>
+          <p:cNvSpPr/>
+          <p:nvPr/>
+        </p:nvSpPr>
+        <p:spPr>
+          <a:xfrm>
+            <a:off x="10515600" y="6400800"/>
+            <a:ext cx="1097280" cy="274320"/>
+          </a:xfrm>
+          <a:prstGeom prst="rect">
+            <a:avLst/>
+          </a:prstGeom>
+          <a:noFill/>
+          <a:ln/>
+        </p:spPr>
+        <p:txBody>
+          <a:bodyPr wrap="square" rtlCol="0" anchor="ctr"/>
+          <a:lstStyle/>
+          <a:p>
+            <a:pPr algn="r" indent="0" marL="0">
+              <a:buNone/>
+            </a:pPr>
+            <a:r>
+              <a:rPr lang="en-US" sz="900" dirty="0">
+                <a:solidFill>
+                  <a:srgbClr val="475569"/>
+                </a:solidFill>
+              </a:rPr>
+              <a:t>Page 40</a:t>
+            </a:r>
+            <a:endParaRPr lang="en-US" sz="900" dirty="0"/>
+          </a:p>
+        </p:txBody>
+      </p:sp>
+      <p:sp>
+        <p:nvSpPr>
+          <p:cNvPr id="6" name="Text 4"/>
+          <p:cNvSpPr/>
+          <p:nvPr/>
+        </p:nvSpPr>
+        <p:spPr>
+          <a:xfrm>
+            <a:off x="548640" y="1371600"/>
+            <a:ext cx="5029200" cy="4389120"/>
+          </a:xfrm>
+          <a:prstGeom prst="rect">
+            <a:avLst/>
+          </a:prstGeom>
+          <a:noFill/>
+          <a:ln/>
+        </p:spPr>
+        <p:txBody>
+          <a:bodyPr wrap="square" rtlCol="0" anchor="ctr"/>
+          <a:lstStyle/>
+          <a:p>
+            <a:pPr indent="0" marL="0">
+              <a:lnSpc>
+                <a:spcPts val="1800"/>
+              </a:lnSpc>
+              <a:buNone/>
+            </a:pPr>
+            <a:r>
+              <a:rPr lang="en-US" sz="1200" dirty="0">
+                <a:solidFill>
+                  <a:srgbClr val="334155"/>
+                </a:solidFill>
+                <a:latin typeface="Arial" pitchFamily="34" charset="0"/>
+                <a:ea typeface="Arial" pitchFamily="34" charset="-122"/>
+                <a:cs typeface="Arial" pitchFamily="34" charset="-120"/>
+              </a:rPr>
+              <a:t>Designed to scale with growing promoter networks and store locations:</a:t>
+            </a:r>
+            <a:endParaRPr lang="en-US" sz="1200" dirty="0"/>
+          </a:p>
+          <a:p>
+            <a:pPr indent="0" marL="0">
+              <a:lnSpc>
+                <a:spcPts val="1800"/>
+              </a:lnSpc>
+              <a:buNone/>
+            </a:pPr>
+            <a:endParaRPr lang="en-US" sz="1200" dirty="0"/>
+          </a:p>
+          <a:p>
+            <a:pPr indent="0" marL="0">
+              <a:lnSpc>
+                <a:spcPts val="1800"/>
+              </a:lnSpc>
+              <a:buNone/>
+            </a:pPr>
+            <a:r>
+              <a:rPr lang="en-US" sz="1200" dirty="0">
+                <a:solidFill>
+                  <a:srgbClr val="334155"/>
+                </a:solidFill>
+                <a:latin typeface="Arial" pitchFamily="34" charset="0"/>
+                <a:ea typeface="Arial" pitchFamily="34" charset="-122"/>
+                <a:cs typeface="Arial" pitchFamily="34" charset="-120"/>
+              </a:rPr>
+              <a:t>• Infrastructure: Light node backend handles thousands of concurrent socket events.</a:t>
+            </a:r>
+            <a:endParaRPr lang="en-US" sz="1200" dirty="0"/>
+          </a:p>
+          <a:p>
+            <a:pPr indent="0" marL="0">
+              <a:lnSpc>
+                <a:spcPts val="1800"/>
+              </a:lnSpc>
+              <a:buNone/>
+            </a:pPr>
+            <a:r>
+              <a:rPr lang="en-US" sz="1200" dirty="0">
+                <a:solidFill>
+                  <a:srgbClr val="334155"/>
+                </a:solidFill>
+                <a:latin typeface="Arial" pitchFamily="34" charset="0"/>
+                <a:ea typeface="Arial" pitchFamily="34" charset="-122"/>
+                <a:cs typeface="Arial" pitchFamily="34" charset="-120"/>
+              </a:rPr>
+              <a:t>• Native Apps: Upcoming iOS and Android wrapper launch to support native notifications.</a:t>
+            </a:r>
+            <a:endParaRPr lang="en-US" sz="1200" dirty="0"/>
+          </a:p>
+          <a:p>
+            <a:pPr indent="0" marL="0">
+              <a:lnSpc>
+                <a:spcPts val="1800"/>
+              </a:lnSpc>
+              <a:buNone/>
+            </a:pPr>
+            <a:r>
+              <a:rPr lang="en-US" sz="1200" dirty="0">
+                <a:solidFill>
+                  <a:srgbClr val="334155"/>
+                </a:solidFill>
+                <a:latin typeface="Arial" pitchFamily="34" charset="0"/>
+                <a:ea typeface="Arial" pitchFamily="34" charset="-122"/>
+                <a:cs typeface="Arial" pitchFamily="34" charset="-120"/>
+              </a:rPr>
+              <a:t>• AI Analytics: Future predictive reports to identify high-turnover stores ahead of time.</a:t>
+            </a:r>
+            <a:endParaRPr lang="en-US" sz="1200" dirty="0"/>
+          </a:p>
+        </p:txBody>
+      </p:sp>
+    </p:spTree>
+  </p:cSld>
+  <p:clrMapOvr>
+    <a:masterClrMapping/>
+  </p:clrMapOvr>
+</p:sld>
+</file>
+
+<file path=ppt/slides/slide41.xml><?xml version="1.0" encoding="utf-8"?>
+<p:sld xmlns:a="http://schemas.openxmlformats.org/drawingml/2006/main" xmlns:r="http://schemas.openxmlformats.org/officeDocument/2006/relationships" xmlns:p="http://schemas.openxmlformats.org/presentationml/2006/main">
+  <p:cSld name="Slide 41">
+    <p:bg>
+      <p:bgPr>
+        <a:solidFill>
           <a:srgbClr val="0F172A"/>
         </a:solidFill>
       </p:bgPr>
@@ -16030,7 +16524,7 @@
                   <a:srgbClr val="475569"/>
                 </a:solidFill>
               </a:rPr>
-              <a:t>Page 40</a:t>
+              <a:t>Page 41</a:t>
             </a:r>
             <a:endParaRPr lang="en-US" sz="900" dirty="0"/>
           </a:p>
@@ -16364,6 +16858,26 @@
                 <a:cs typeface="Arial" pitchFamily="34" charset="-120"/>
               </a:rPr>
               <a:t>• Client: View external audits, project summaries, and dashboard statistics.</a:t>
+            </a:r>
+            <a:endParaRPr lang="en-US" sz="1200" dirty="0"/>
+          </a:p>
+          <a:p>
+            <a:pPr indent="0" marL="0">
+              <a:lnSpc>
+                <a:spcPts val="1800"/>
+              </a:lnSpc>
+              <a:buNone/>
+            </a:pPr>
+            <a:r>
+              <a:rPr lang="en-US" sz="1200" dirty="0">
+                <a:solidFill>
+                  <a:srgbClr val="334155"/>
+                </a:solidFill>
+                <a:latin typeface="Arial" pitchFamily="34" charset="0"/>
+                <a:ea typeface="Arial" pitchFamily="34" charset="-122"/>
+                <a:cs typeface="Arial" pitchFamily="34" charset="-120"/>
+              </a:rPr>
+              <a:t>• Marketing Manager: View campaign readiness and live quiz statistics.</a:t>
             </a:r>
             <a:endParaRPr lang="en-US" sz="1200" dirty="0"/>
           </a:p>

</xml_diff>